<commit_message>
Add a single prominent docs link in the README; update pitch deck
</commit_message>
<xml_diff>
--- a/presentation/PingIt_Pitch.pptx
+++ b/presentation/PingIt_Pitch.pptx
@@ -5,16 +5,15 @@
     <p:sldMasterId id="2147483648" r:id="rId1"/>
   </p:sldMasterIdLst>
   <p:sldIdLst>
-    <p:sldId id="256" r:id="rId7"/>
-    <p:sldId id="257" r:id="rId8"/>
-    <p:sldId id="258" r:id="rId9"/>
-    <p:sldId id="259" r:id="rId10"/>
-    <p:sldId id="260" r:id="rId11"/>
-    <p:sldId id="261" r:id="rId12"/>
-    <p:sldId id="262" r:id="rId13"/>
-    <p:sldId id="263" r:id="rId14"/>
+    <p:sldId id="256" r:id="rId2"/>
+    <p:sldId id="257" r:id="rId3"/>
+    <p:sldId id="258" r:id="rId4"/>
+    <p:sldId id="259" r:id="rId5"/>
+    <p:sldId id="260" r:id="rId6"/>
+    <p:sldId id="261" r:id="rId7"/>
+    <p:sldId id="262" r:id="rId8"/>
   </p:sldIdLst>
-  <p:sldSz cx="12191695" cy="6858000" type="screen4x3"/>
+  <p:sldSz cx="12192000" cy="6858000"/>
   <p:notesSz cx="6858000" cy="9144000"/>
   <p:defaultTextStyle>
     <a:defPPr>
@@ -111,6 +110,22 @@
       </a:defRPr>
     </a:lvl9pPr>
   </p:defaultTextStyle>
+  <p:extLst>
+    <p:ext uri="{EFAFB233-063F-42B5-8137-9DF3F51BA10A}">
+      <p15:sldGuideLst xmlns:p15="http://schemas.microsoft.com/office/powerpoint/2012/main">
+        <p15:guide id="1" orient="horz" pos="2160">
+          <p15:clr>
+            <a:srgbClr val="A4A3A4"/>
+          </p15:clr>
+        </p15:guide>
+        <p15:guide id="2" pos="2880">
+          <p15:clr>
+            <a:srgbClr val="A4A3A4"/>
+          </p15:clr>
+        </p15:guide>
+      </p15:sldGuideLst>
+    </p:ext>
+  </p:extLst>
 </p:presentation>
 </file>
 
@@ -152,10 +167,9 @@
           <a:lstStyle/>
           <a:p>
             <a:r>
-              <a:rPr lang="en-US" smtClean="0"/>
+              <a:rPr lang="en-US"/>
               <a:t>Click to edit Master title style</a:t>
             </a:r>
-            <a:endParaRPr lang="en-US"/>
           </a:p>
         </p:txBody>
       </p:sp>
@@ -271,10 +285,9 @@
           </a:lstStyle>
           <a:p>
             <a:r>
-              <a:rPr lang="en-US" smtClean="0"/>
+              <a:rPr lang="en-US"/>
               <a:t>Click to edit Master subtitle style</a:t>
             </a:r>
-            <a:endParaRPr lang="en-US"/>
           </a:p>
         </p:txBody>
       </p:sp>
@@ -295,7 +308,7 @@
           <a:p>
             <a:fld id="{5BCAD085-E8A6-8845-BD4E-CB4CCA059FC4}" type="datetimeFigureOut">
               <a:rPr lang="en-US" smtClean="0"/>
-              <a:t>1/27/13</a:t>
+              <a:t>7/7/26</a:t>
             </a:fld>
             <a:endParaRPr lang="en-US"/>
           </a:p>
@@ -389,10 +402,9 @@
           <a:lstStyle/>
           <a:p>
             <a:r>
-              <a:rPr lang="en-US" smtClean="0"/>
+              <a:rPr lang="en-US"/>
               <a:t>Click to edit Master title style</a:t>
             </a:r>
-            <a:endParaRPr lang="en-US"/>
           </a:p>
         </p:txBody>
       </p:sp>
@@ -413,38 +425,37 @@
           <a:p>
             <a:pPr lvl="0"/>
             <a:r>
-              <a:rPr lang="en-US" smtClean="0"/>
+              <a:rPr lang="en-US"/>
               <a:t>Click to edit Master text styles</a:t>
             </a:r>
           </a:p>
           <a:p>
             <a:pPr lvl="1"/>
             <a:r>
-              <a:rPr lang="en-US" smtClean="0"/>
+              <a:rPr lang="en-US"/>
               <a:t>Second level</a:t>
             </a:r>
           </a:p>
           <a:p>
             <a:pPr lvl="2"/>
             <a:r>
-              <a:rPr lang="en-US" smtClean="0"/>
+              <a:rPr lang="en-US"/>
               <a:t>Third level</a:t>
             </a:r>
           </a:p>
           <a:p>
             <a:pPr lvl="3"/>
             <a:r>
-              <a:rPr lang="en-US" smtClean="0"/>
+              <a:rPr lang="en-US"/>
               <a:t>Fourth level</a:t>
             </a:r>
           </a:p>
           <a:p>
             <a:pPr lvl="4"/>
             <a:r>
-              <a:rPr lang="en-US" smtClean="0"/>
+              <a:rPr lang="en-US"/>
               <a:t>Fifth level</a:t>
             </a:r>
-            <a:endParaRPr lang="en-US"/>
           </a:p>
         </p:txBody>
       </p:sp>
@@ -465,7 +476,7 @@
           <a:p>
             <a:fld id="{5BCAD085-E8A6-8845-BD4E-CB4CCA059FC4}" type="datetimeFigureOut">
               <a:rPr lang="en-US" smtClean="0"/>
-              <a:t>1/27/13</a:t>
+              <a:t>7/7/26</a:t>
             </a:fld>
             <a:endParaRPr lang="en-US"/>
           </a:p>
@@ -564,10 +575,9 @@
           <a:lstStyle/>
           <a:p>
             <a:r>
-              <a:rPr lang="en-US" smtClean="0"/>
+              <a:rPr lang="en-US"/>
               <a:t>Click to edit Master title style</a:t>
             </a:r>
-            <a:endParaRPr lang="en-US"/>
           </a:p>
         </p:txBody>
       </p:sp>
@@ -593,38 +603,37 @@
           <a:p>
             <a:pPr lvl="0"/>
             <a:r>
-              <a:rPr lang="en-US" smtClean="0"/>
+              <a:rPr lang="en-US"/>
               <a:t>Click to edit Master text styles</a:t>
             </a:r>
           </a:p>
           <a:p>
             <a:pPr lvl="1"/>
             <a:r>
-              <a:rPr lang="en-US" smtClean="0"/>
+              <a:rPr lang="en-US"/>
               <a:t>Second level</a:t>
             </a:r>
           </a:p>
           <a:p>
             <a:pPr lvl="2"/>
             <a:r>
-              <a:rPr lang="en-US" smtClean="0"/>
+              <a:rPr lang="en-US"/>
               <a:t>Third level</a:t>
             </a:r>
           </a:p>
           <a:p>
             <a:pPr lvl="3"/>
             <a:r>
-              <a:rPr lang="en-US" smtClean="0"/>
+              <a:rPr lang="en-US"/>
               <a:t>Fourth level</a:t>
             </a:r>
           </a:p>
           <a:p>
             <a:pPr lvl="4"/>
             <a:r>
-              <a:rPr lang="en-US" smtClean="0"/>
+              <a:rPr lang="en-US"/>
               <a:t>Fifth level</a:t>
             </a:r>
-            <a:endParaRPr lang="en-US"/>
           </a:p>
         </p:txBody>
       </p:sp>
@@ -645,7 +654,7 @@
           <a:p>
             <a:fld id="{5BCAD085-E8A6-8845-BD4E-CB4CCA059FC4}" type="datetimeFigureOut">
               <a:rPr lang="en-US" smtClean="0"/>
-              <a:t>1/27/13</a:t>
+              <a:t>7/7/26</a:t>
             </a:fld>
             <a:endParaRPr lang="en-US"/>
           </a:p>
@@ -739,10 +748,9 @@
           <a:lstStyle/>
           <a:p>
             <a:r>
-              <a:rPr lang="en-US" smtClean="0"/>
+              <a:rPr lang="en-US"/>
               <a:t>Click to edit Master title style</a:t>
             </a:r>
-            <a:endParaRPr lang="en-US"/>
           </a:p>
         </p:txBody>
       </p:sp>
@@ -763,38 +771,37 @@
           <a:p>
             <a:pPr lvl="0"/>
             <a:r>
-              <a:rPr lang="en-US" smtClean="0"/>
+              <a:rPr lang="en-US"/>
               <a:t>Click to edit Master text styles</a:t>
             </a:r>
           </a:p>
           <a:p>
             <a:pPr lvl="1"/>
             <a:r>
-              <a:rPr lang="en-US" smtClean="0"/>
+              <a:rPr lang="en-US"/>
               <a:t>Second level</a:t>
             </a:r>
           </a:p>
           <a:p>
             <a:pPr lvl="2"/>
             <a:r>
-              <a:rPr lang="en-US" smtClean="0"/>
+              <a:rPr lang="en-US"/>
               <a:t>Third level</a:t>
             </a:r>
           </a:p>
           <a:p>
             <a:pPr lvl="3"/>
             <a:r>
-              <a:rPr lang="en-US" smtClean="0"/>
+              <a:rPr lang="en-US"/>
               <a:t>Fourth level</a:t>
             </a:r>
           </a:p>
           <a:p>
             <a:pPr lvl="4"/>
             <a:r>
-              <a:rPr lang="en-US" smtClean="0"/>
+              <a:rPr lang="en-US"/>
               <a:t>Fifth level</a:t>
             </a:r>
-            <a:endParaRPr lang="en-US"/>
           </a:p>
         </p:txBody>
       </p:sp>
@@ -815,7 +822,7 @@
           <a:p>
             <a:fld id="{5BCAD085-E8A6-8845-BD4E-CB4CCA059FC4}" type="datetimeFigureOut">
               <a:rPr lang="en-US" smtClean="0"/>
-              <a:t>1/27/13</a:t>
+              <a:t>7/7/26</a:t>
             </a:fld>
             <a:endParaRPr lang="en-US"/>
           </a:p>
@@ -918,10 +925,9 @@
           </a:lstStyle>
           <a:p>
             <a:r>
-              <a:rPr lang="en-US" smtClean="0"/>
+              <a:rPr lang="en-US"/>
               <a:t>Click to edit Master title style</a:t>
             </a:r>
-            <a:endParaRPr lang="en-US"/>
           </a:p>
         </p:txBody>
       </p:sp>
@@ -1038,7 +1044,7 @@
           <a:p>
             <a:pPr lvl="0"/>
             <a:r>
-              <a:rPr lang="en-US" smtClean="0"/>
+              <a:rPr lang="en-US"/>
               <a:t>Click to edit Master text styles</a:t>
             </a:r>
           </a:p>
@@ -1061,7 +1067,7 @@
           <a:p>
             <a:fld id="{5BCAD085-E8A6-8845-BD4E-CB4CCA059FC4}" type="datetimeFigureOut">
               <a:rPr lang="en-US" smtClean="0"/>
-              <a:t>1/27/13</a:t>
+              <a:t>7/7/26</a:t>
             </a:fld>
             <a:endParaRPr lang="en-US"/>
           </a:p>
@@ -1155,10 +1161,9 @@
           <a:lstStyle/>
           <a:p>
             <a:r>
-              <a:rPr lang="en-US" smtClean="0"/>
+              <a:rPr lang="en-US"/>
               <a:t>Click to edit Master title style</a:t>
             </a:r>
-            <a:endParaRPr lang="en-US"/>
           </a:p>
         </p:txBody>
       </p:sp>
@@ -1212,38 +1217,37 @@
           <a:p>
             <a:pPr lvl="0"/>
             <a:r>
-              <a:rPr lang="en-US" smtClean="0"/>
+              <a:rPr lang="en-US"/>
               <a:t>Click to edit Master text styles</a:t>
             </a:r>
           </a:p>
           <a:p>
             <a:pPr lvl="1"/>
             <a:r>
-              <a:rPr lang="en-US" smtClean="0"/>
+              <a:rPr lang="en-US"/>
               <a:t>Second level</a:t>
             </a:r>
           </a:p>
           <a:p>
             <a:pPr lvl="2"/>
             <a:r>
-              <a:rPr lang="en-US" smtClean="0"/>
+              <a:rPr lang="en-US"/>
               <a:t>Third level</a:t>
             </a:r>
           </a:p>
           <a:p>
             <a:pPr lvl="3"/>
             <a:r>
-              <a:rPr lang="en-US" smtClean="0"/>
+              <a:rPr lang="en-US"/>
               <a:t>Fourth level</a:t>
             </a:r>
           </a:p>
           <a:p>
             <a:pPr lvl="4"/>
             <a:r>
-              <a:rPr lang="en-US" smtClean="0"/>
+              <a:rPr lang="en-US"/>
               <a:t>Fifth level</a:t>
             </a:r>
-            <a:endParaRPr lang="en-US"/>
           </a:p>
         </p:txBody>
       </p:sp>
@@ -1297,38 +1301,37 @@
           <a:p>
             <a:pPr lvl="0"/>
             <a:r>
-              <a:rPr lang="en-US" smtClean="0"/>
+              <a:rPr lang="en-US"/>
               <a:t>Click to edit Master text styles</a:t>
             </a:r>
           </a:p>
           <a:p>
             <a:pPr lvl="1"/>
             <a:r>
-              <a:rPr lang="en-US" smtClean="0"/>
+              <a:rPr lang="en-US"/>
               <a:t>Second level</a:t>
             </a:r>
           </a:p>
           <a:p>
             <a:pPr lvl="2"/>
             <a:r>
-              <a:rPr lang="en-US" smtClean="0"/>
+              <a:rPr lang="en-US"/>
               <a:t>Third level</a:t>
             </a:r>
           </a:p>
           <a:p>
             <a:pPr lvl="3"/>
             <a:r>
-              <a:rPr lang="en-US" smtClean="0"/>
+              <a:rPr lang="en-US"/>
               <a:t>Fourth level</a:t>
             </a:r>
           </a:p>
           <a:p>
             <a:pPr lvl="4"/>
             <a:r>
-              <a:rPr lang="en-US" smtClean="0"/>
+              <a:rPr lang="en-US"/>
               <a:t>Fifth level</a:t>
             </a:r>
-            <a:endParaRPr lang="en-US"/>
           </a:p>
         </p:txBody>
       </p:sp>
@@ -1349,7 +1352,7 @@
           <a:p>
             <a:fld id="{5BCAD085-E8A6-8845-BD4E-CB4CCA059FC4}" type="datetimeFigureOut">
               <a:rPr lang="en-US" smtClean="0"/>
-              <a:t>1/27/13</a:t>
+              <a:t>7/7/26</a:t>
             </a:fld>
             <a:endParaRPr lang="en-US"/>
           </a:p>
@@ -1447,10 +1450,9 @@
           </a:lstStyle>
           <a:p>
             <a:r>
-              <a:rPr lang="en-US" smtClean="0"/>
+              <a:rPr lang="en-US"/>
               <a:t>Click to edit Master title style</a:t>
             </a:r>
-            <a:endParaRPr lang="en-US"/>
           </a:p>
         </p:txBody>
       </p:sp>
@@ -1513,7 +1515,7 @@
           <a:p>
             <a:pPr lvl="0"/>
             <a:r>
-              <a:rPr lang="en-US" smtClean="0"/>
+              <a:rPr lang="en-US"/>
               <a:t>Click to edit Master text styles</a:t>
             </a:r>
           </a:p>
@@ -1569,38 +1571,37 @@
           <a:p>
             <a:pPr lvl="0"/>
             <a:r>
-              <a:rPr lang="en-US" smtClean="0"/>
+              <a:rPr lang="en-US"/>
               <a:t>Click to edit Master text styles</a:t>
             </a:r>
           </a:p>
           <a:p>
             <a:pPr lvl="1"/>
             <a:r>
-              <a:rPr lang="en-US" smtClean="0"/>
+              <a:rPr lang="en-US"/>
               <a:t>Second level</a:t>
             </a:r>
           </a:p>
           <a:p>
             <a:pPr lvl="2"/>
             <a:r>
-              <a:rPr lang="en-US" smtClean="0"/>
+              <a:rPr lang="en-US"/>
               <a:t>Third level</a:t>
             </a:r>
           </a:p>
           <a:p>
             <a:pPr lvl="3"/>
             <a:r>
-              <a:rPr lang="en-US" smtClean="0"/>
+              <a:rPr lang="en-US"/>
               <a:t>Fourth level</a:t>
             </a:r>
           </a:p>
           <a:p>
             <a:pPr lvl="4"/>
             <a:r>
-              <a:rPr lang="en-US" smtClean="0"/>
+              <a:rPr lang="en-US"/>
               <a:t>Fifth level</a:t>
             </a:r>
-            <a:endParaRPr lang="en-US"/>
           </a:p>
         </p:txBody>
       </p:sp>
@@ -1663,7 +1664,7 @@
           <a:p>
             <a:pPr lvl="0"/>
             <a:r>
-              <a:rPr lang="en-US" smtClean="0"/>
+              <a:rPr lang="en-US"/>
               <a:t>Click to edit Master text styles</a:t>
             </a:r>
           </a:p>
@@ -1719,38 +1720,37 @@
           <a:p>
             <a:pPr lvl="0"/>
             <a:r>
-              <a:rPr lang="en-US" smtClean="0"/>
+              <a:rPr lang="en-US"/>
               <a:t>Click to edit Master text styles</a:t>
             </a:r>
           </a:p>
           <a:p>
             <a:pPr lvl="1"/>
             <a:r>
-              <a:rPr lang="en-US" smtClean="0"/>
+              <a:rPr lang="en-US"/>
               <a:t>Second level</a:t>
             </a:r>
           </a:p>
           <a:p>
             <a:pPr lvl="2"/>
             <a:r>
-              <a:rPr lang="en-US" smtClean="0"/>
+              <a:rPr lang="en-US"/>
               <a:t>Third level</a:t>
             </a:r>
           </a:p>
           <a:p>
             <a:pPr lvl="3"/>
             <a:r>
-              <a:rPr lang="en-US" smtClean="0"/>
+              <a:rPr lang="en-US"/>
               <a:t>Fourth level</a:t>
             </a:r>
           </a:p>
           <a:p>
             <a:pPr lvl="4"/>
             <a:r>
-              <a:rPr lang="en-US" smtClean="0"/>
+              <a:rPr lang="en-US"/>
               <a:t>Fifth level</a:t>
             </a:r>
-            <a:endParaRPr lang="en-US"/>
           </a:p>
         </p:txBody>
       </p:sp>
@@ -1771,7 +1771,7 @@
           <a:p>
             <a:fld id="{5BCAD085-E8A6-8845-BD4E-CB4CCA059FC4}" type="datetimeFigureOut">
               <a:rPr lang="en-US" smtClean="0"/>
-              <a:t>1/27/13</a:t>
+              <a:t>7/7/26</a:t>
             </a:fld>
             <a:endParaRPr lang="en-US"/>
           </a:p>
@@ -1865,10 +1865,9 @@
           <a:lstStyle/>
           <a:p>
             <a:r>
-              <a:rPr lang="en-US" smtClean="0"/>
+              <a:rPr lang="en-US"/>
               <a:t>Click to edit Master title style</a:t>
             </a:r>
-            <a:endParaRPr lang="en-US"/>
           </a:p>
         </p:txBody>
       </p:sp>
@@ -1889,7 +1888,7 @@
           <a:p>
             <a:fld id="{5BCAD085-E8A6-8845-BD4E-CB4CCA059FC4}" type="datetimeFigureOut">
               <a:rPr lang="en-US" smtClean="0"/>
-              <a:t>1/27/13</a:t>
+              <a:t>7/7/26</a:t>
             </a:fld>
             <a:endParaRPr lang="en-US"/>
           </a:p>
@@ -1984,7 +1983,7 @@
           <a:p>
             <a:fld id="{5BCAD085-E8A6-8845-BD4E-CB4CCA059FC4}" type="datetimeFigureOut">
               <a:rPr lang="en-US" smtClean="0"/>
-              <a:t>1/27/13</a:t>
+              <a:t>7/7/26</a:t>
             </a:fld>
             <a:endParaRPr lang="en-US"/>
           </a:p>
@@ -2087,10 +2086,9 @@
           </a:lstStyle>
           <a:p>
             <a:r>
-              <a:rPr lang="en-US" smtClean="0"/>
+              <a:rPr lang="en-US"/>
               <a:t>Click to edit Master title style</a:t>
             </a:r>
-            <a:endParaRPr lang="en-US"/>
           </a:p>
         </p:txBody>
       </p:sp>
@@ -2144,38 +2142,37 @@
           <a:p>
             <a:pPr lvl="0"/>
             <a:r>
-              <a:rPr lang="en-US" smtClean="0"/>
+              <a:rPr lang="en-US"/>
               <a:t>Click to edit Master text styles</a:t>
             </a:r>
           </a:p>
           <a:p>
             <a:pPr lvl="1"/>
             <a:r>
-              <a:rPr lang="en-US" smtClean="0"/>
+              <a:rPr lang="en-US"/>
               <a:t>Second level</a:t>
             </a:r>
           </a:p>
           <a:p>
             <a:pPr lvl="2"/>
             <a:r>
-              <a:rPr lang="en-US" smtClean="0"/>
+              <a:rPr lang="en-US"/>
               <a:t>Third level</a:t>
             </a:r>
           </a:p>
           <a:p>
             <a:pPr lvl="3"/>
             <a:r>
-              <a:rPr lang="en-US" smtClean="0"/>
+              <a:rPr lang="en-US"/>
               <a:t>Fourth level</a:t>
             </a:r>
           </a:p>
           <a:p>
             <a:pPr lvl="4"/>
             <a:r>
-              <a:rPr lang="en-US" smtClean="0"/>
+              <a:rPr lang="en-US"/>
               <a:t>Fifth level</a:t>
             </a:r>
-            <a:endParaRPr lang="en-US"/>
           </a:p>
         </p:txBody>
       </p:sp>
@@ -2238,7 +2235,7 @@
           <a:p>
             <a:pPr lvl="0"/>
             <a:r>
-              <a:rPr lang="en-US" smtClean="0"/>
+              <a:rPr lang="en-US"/>
               <a:t>Click to edit Master text styles</a:t>
             </a:r>
           </a:p>
@@ -2261,7 +2258,7 @@
           <a:p>
             <a:fld id="{5BCAD085-E8A6-8845-BD4E-CB4CCA059FC4}" type="datetimeFigureOut">
               <a:rPr lang="en-US" smtClean="0"/>
-              <a:t>1/27/13</a:t>
+              <a:t>7/7/26</a:t>
             </a:fld>
             <a:endParaRPr lang="en-US"/>
           </a:p>
@@ -2364,10 +2361,9 @@
           </a:lstStyle>
           <a:p>
             <a:r>
-              <a:rPr lang="en-US" smtClean="0"/>
+              <a:rPr lang="en-US"/>
               <a:t>Click to edit Master title style</a:t>
             </a:r>
-            <a:endParaRPr lang="en-US"/>
           </a:p>
         </p:txBody>
       </p:sp>
@@ -2491,7 +2487,7 @@
           <a:p>
             <a:pPr lvl="0"/>
             <a:r>
-              <a:rPr lang="en-US" smtClean="0"/>
+              <a:rPr lang="en-US"/>
               <a:t>Click to edit Master text styles</a:t>
             </a:r>
           </a:p>
@@ -2514,7 +2510,7 @@
           <a:p>
             <a:fld id="{5BCAD085-E8A6-8845-BD4E-CB4CCA059FC4}" type="datetimeFigureOut">
               <a:rPr lang="en-US" smtClean="0"/>
-              <a:t>1/27/13</a:t>
+              <a:t>7/7/26</a:t>
             </a:fld>
             <a:endParaRPr lang="en-US"/>
           </a:p>
@@ -2623,10 +2619,9 @@
           <a:lstStyle/>
           <a:p>
             <a:r>
-              <a:rPr lang="en-US" smtClean="0"/>
+              <a:rPr lang="en-US"/>
               <a:t>Click to edit Master title style</a:t>
             </a:r>
-            <a:endParaRPr lang="en-US"/>
           </a:p>
         </p:txBody>
       </p:sp>
@@ -2657,38 +2652,37 @@
           <a:p>
             <a:pPr lvl="0"/>
             <a:r>
-              <a:rPr lang="en-US" smtClean="0"/>
+              <a:rPr lang="en-US"/>
               <a:t>Click to edit Master text styles</a:t>
             </a:r>
           </a:p>
           <a:p>
             <a:pPr lvl="1"/>
             <a:r>
-              <a:rPr lang="en-US" smtClean="0"/>
+              <a:rPr lang="en-US"/>
               <a:t>Second level</a:t>
             </a:r>
           </a:p>
           <a:p>
             <a:pPr lvl="2"/>
             <a:r>
-              <a:rPr lang="en-US" smtClean="0"/>
+              <a:rPr lang="en-US"/>
               <a:t>Third level</a:t>
             </a:r>
           </a:p>
           <a:p>
             <a:pPr lvl="3"/>
             <a:r>
-              <a:rPr lang="en-US" smtClean="0"/>
+              <a:rPr lang="en-US"/>
               <a:t>Fourth level</a:t>
             </a:r>
           </a:p>
           <a:p>
             <a:pPr lvl="4"/>
             <a:r>
-              <a:rPr lang="en-US" smtClean="0"/>
+              <a:rPr lang="en-US"/>
               <a:t>Fifth level</a:t>
             </a:r>
-            <a:endParaRPr lang="en-US"/>
           </a:p>
         </p:txBody>
       </p:sp>
@@ -2727,7 +2721,7 @@
           <a:p>
             <a:fld id="{5BCAD085-E8A6-8845-BD4E-CB4CCA059FC4}" type="datetimeFigureOut">
               <a:rPr lang="en-US" smtClean="0"/>
-              <a:t>1/27/13</a:t>
+              <a:t>7/7/26</a:t>
             </a:fld>
             <a:endParaRPr lang="en-US"/>
           </a:p>
@@ -3086,7 +3080,7 @@
 </file>
 
 <file path=ppt/slides/slide1.xml><?xml version="1.0" encoding="utf-8"?>
-<p:sld xmlns:a="http://schemas.openxmlformats.org/drawingml/2006/main" xmlns:p="http://schemas.openxmlformats.org/presentationml/2006/main" xmlns:r="http://schemas.openxmlformats.org/officeDocument/2006/relationships">
+<p:sld xmlns:a="http://schemas.openxmlformats.org/drawingml/2006/main" xmlns:r="http://schemas.openxmlformats.org/officeDocument/2006/relationships" xmlns:p="http://schemas.openxmlformats.org/presentationml/2006/main">
   <p:cSld>
     <p:spTree>
       <p:nvGrpSpPr>
@@ -3094,7 +3088,14 @@
         <p:cNvGrpSpPr/>
         <p:nvPr/>
       </p:nvGrpSpPr>
-      <p:grpSpPr/>
+      <p:grpSpPr>
+        <a:xfrm>
+          <a:off x="0" y="0"/>
+          <a:ext cx="0" cy="0"/>
+          <a:chOff x="0" y="0"/>
+          <a:chExt cx="0" cy="0"/>
+        </a:xfrm>
+      </p:grpSpPr>
       <p:sp>
         <p:nvSpPr>
           <p:cNvPr id="2" name="Rectangle 1"/>
@@ -3135,6 +3136,7 @@
           <a:lstStyle/>
           <a:p>
             <a:pPr algn="ctr"/>
+            <a:endParaRPr/>
           </a:p>
         </p:txBody>
       </p:sp>
@@ -3178,6 +3180,7 @@
           <a:lstStyle/>
           <a:p>
             <a:pPr algn="ctr"/>
+            <a:endParaRPr/>
           </a:p>
         </p:txBody>
       </p:sp>
@@ -3221,41 +3224,7 @@
           <a:lstStyle/>
           <a:p>
             <a:pPr algn="ctr"/>
-          </a:p>
-        </p:txBody>
-      </p:sp>
-      <p:sp>
-        <p:nvSpPr>
-          <p:cNvPr id="5" name="TextBox 4"/>
-          <p:cNvSpPr txBox="1"/>
-          <p:nvPr/>
-        </p:nvSpPr>
-        <p:spPr>
-          <a:xfrm>
-            <a:off x="822960" y="868680"/>
-            <a:ext cx="10058400" cy="365760"/>
-          </a:xfrm>
-          <a:prstGeom prst="rect">
-            <a:avLst/>
-          </a:prstGeom>
-          <a:noFill/>
-        </p:spPr>
-        <p:txBody>
-          <a:bodyPr wrap="square" anchor="t" lIns="0" rIns="0" tIns="0" bIns="0">
-            <a:spAutoFit/>
-          </a:bodyPr>
-          <a:lstStyle/>
-          <a:p>
-            <a:pPr algn="l"/>
-            <a:r>
-              <a:rPr sz="1300" b="1" i="0" spc="220">
-                <a:solidFill>
-                  <a:srgbClr val="C24E17"/>
-                </a:solidFill>
-                <a:latin typeface="Arial"/>
-              </a:rPr>
-              <a:t>NETWORK-QUALITY SDK  ·  FOR DEVELOPERS</a:t>
-            </a:r>
+            <a:endParaRPr/>
           </a:p>
         </p:txBody>
       </p:sp>
@@ -3276,7 +3245,7 @@
           <a:noFill/>
         </p:spPr>
         <p:txBody>
-          <a:bodyPr wrap="square" anchor="t" lIns="0" rIns="0" tIns="0" bIns="0">
+          <a:bodyPr wrap="square" lIns="0" tIns="0" rIns="0" bIns="0" anchor="t">
             <a:spAutoFit/>
           </a:bodyPr>
           <a:lstStyle/>
@@ -3334,6 +3303,7 @@
           <a:lstStyle/>
           <a:p>
             <a:pPr algn="ctr"/>
+            <a:endParaRPr/>
           </a:p>
         </p:txBody>
       </p:sp>
@@ -3354,7 +3324,7 @@
           <a:noFill/>
         </p:spPr>
         <p:txBody>
-          <a:bodyPr wrap="square" anchor="t" lIns="0" rIns="0" tIns="0" bIns="0">
+          <a:bodyPr wrap="square" lIns="0" tIns="0" rIns="0" bIns="0" anchor="t">
             <a:spAutoFit/>
           </a:bodyPr>
           <a:lstStyle/>
@@ -3368,41 +3338,6 @@
                 <a:latin typeface="Arial"/>
               </a:rPr>
               <a:t>Know the network before your app needs it.</a:t>
-            </a:r>
-          </a:p>
-        </p:txBody>
-      </p:sp>
-      <p:sp>
-        <p:nvSpPr>
-          <p:cNvPr id="9" name="TextBox 8"/>
-          <p:cNvSpPr txBox="1"/>
-          <p:nvPr/>
-        </p:nvSpPr>
-        <p:spPr>
-          <a:xfrm>
-            <a:off x="822960" y="5943600"/>
-            <a:ext cx="8229600" cy="457200"/>
-          </a:xfrm>
-          <a:prstGeom prst="rect">
-            <a:avLst/>
-          </a:prstGeom>
-          <a:noFill/>
-        </p:spPr>
-        <p:txBody>
-          <a:bodyPr wrap="square" anchor="t" lIns="0" rIns="0" tIns="0" bIns="0">
-            <a:spAutoFit/>
-          </a:bodyPr>
-          <a:lstStyle/>
-          <a:p>
-            <a:pPr algn="l"/>
-            <a:r>
-              <a:rPr sz="1500" b="0" i="0">
-                <a:solidFill>
-                  <a:srgbClr val="8A7C6E"/>
-                </a:solidFill>
-                <a:latin typeface="Arial"/>
-              </a:rPr>
-              <a:t>A 4-minute intro for the developers who'd build with it.</a:t>
             </a:r>
           </a:p>
         </p:txBody>
@@ -3416,7 +3351,7 @@
 </file>
 
 <file path=ppt/slides/slide2.xml><?xml version="1.0" encoding="utf-8"?>
-<p:sld xmlns:a="http://schemas.openxmlformats.org/drawingml/2006/main" xmlns:p="http://schemas.openxmlformats.org/presentationml/2006/main" xmlns:r="http://schemas.openxmlformats.org/officeDocument/2006/relationships">
+<p:sld xmlns:a="http://schemas.openxmlformats.org/drawingml/2006/main" xmlns:r="http://schemas.openxmlformats.org/officeDocument/2006/relationships" xmlns:p="http://schemas.openxmlformats.org/presentationml/2006/main">
   <p:cSld>
     <p:spTree>
       <p:nvGrpSpPr>
@@ -3424,7 +3359,14 @@
         <p:cNvGrpSpPr/>
         <p:nvPr/>
       </p:nvGrpSpPr>
-      <p:grpSpPr/>
+      <p:grpSpPr>
+        <a:xfrm>
+          <a:off x="0" y="0"/>
+          <a:ext cx="0" cy="0"/>
+          <a:chOff x="0" y="0"/>
+          <a:chExt cx="0" cy="0"/>
+        </a:xfrm>
+      </p:grpSpPr>
       <p:sp>
         <p:nvSpPr>
           <p:cNvPr id="2" name="Rectangle 1"/>
@@ -3465,6 +3407,7 @@
           <a:lstStyle/>
           <a:p>
             <a:pPr algn="ctr"/>
+            <a:endParaRPr/>
           </a:p>
         </p:txBody>
       </p:sp>
@@ -3485,7 +3428,7 @@
           <a:noFill/>
         </p:spPr>
         <p:txBody>
-          <a:bodyPr wrap="square" anchor="t" lIns="0" rIns="0" tIns="0" bIns="0">
+          <a:bodyPr wrap="square" lIns="0" tIns="0" rIns="0" bIns="0" anchor="t">
             <a:spAutoFit/>
           </a:bodyPr>
           <a:lstStyle/>
@@ -3520,7 +3463,7 @@
           <a:noFill/>
         </p:spPr>
         <p:txBody>
-          <a:bodyPr wrap="square" anchor="t" lIns="0" rIns="0" tIns="0" bIns="0">
+          <a:bodyPr wrap="square" lIns="0" tIns="0" rIns="0" bIns="0" anchor="t">
             <a:spAutoFit/>
           </a:bodyPr>
           <a:lstStyle/>
@@ -3559,7 +3502,7 @@
           <a:noFill/>
         </p:spPr>
         <p:txBody>
-          <a:bodyPr wrap="square" anchor="t" lIns="0" rIns="0" tIns="0" bIns="0">
+          <a:bodyPr wrap="square" lIns="0" tIns="0" rIns="0" bIns="0" anchor="t">
             <a:spAutoFit/>
           </a:bodyPr>
           <a:lstStyle/>
@@ -3570,7 +3513,7 @@
               </a:lnSpc>
             </a:pPr>
             <a:r>
-              <a:rPr sz="2200" b="0" i="0">
+              <a:rPr sz="2200" b="0" i="0" dirty="0">
                 <a:solidFill>
                   <a:srgbClr val="8A7C6E"/>
                 </a:solidFill>
@@ -3621,6 +3564,7 @@
           <a:lstStyle/>
           <a:p>
             <a:pPr algn="ctr"/>
+            <a:endParaRPr/>
           </a:p>
         </p:txBody>
       </p:sp>
@@ -3633,7 +3577,7 @@
 </file>
 
 <file path=ppt/slides/slide3.xml><?xml version="1.0" encoding="utf-8"?>
-<p:sld xmlns:a="http://schemas.openxmlformats.org/drawingml/2006/main" xmlns:p="http://schemas.openxmlformats.org/presentationml/2006/main" xmlns:r="http://schemas.openxmlformats.org/officeDocument/2006/relationships">
+<p:sld xmlns:a="http://schemas.openxmlformats.org/drawingml/2006/main" xmlns:r="http://schemas.openxmlformats.org/officeDocument/2006/relationships" xmlns:p="http://schemas.openxmlformats.org/presentationml/2006/main">
   <p:cSld>
     <p:spTree>
       <p:nvGrpSpPr>
@@ -3641,7 +3585,14 @@
         <p:cNvGrpSpPr/>
         <p:nvPr/>
       </p:nvGrpSpPr>
-      <p:grpSpPr/>
+      <p:grpSpPr>
+        <a:xfrm>
+          <a:off x="0" y="0"/>
+          <a:ext cx="0" cy="0"/>
+          <a:chOff x="0" y="0"/>
+          <a:chExt cx="0" cy="0"/>
+        </a:xfrm>
+      </p:grpSpPr>
       <p:sp>
         <p:nvSpPr>
           <p:cNvPr id="2" name="Rectangle 1"/>
@@ -3682,6 +3633,7 @@
           <a:lstStyle/>
           <a:p>
             <a:pPr algn="ctr"/>
+            <a:endParaRPr/>
           </a:p>
         </p:txBody>
       </p:sp>
@@ -3702,7 +3654,7 @@
           <a:noFill/>
         </p:spPr>
         <p:txBody>
-          <a:bodyPr wrap="square" anchor="t" lIns="0" rIns="0" tIns="0" bIns="0">
+          <a:bodyPr wrap="square" lIns="0" tIns="0" rIns="0" bIns="0" anchor="t">
             <a:spAutoFit/>
           </a:bodyPr>
           <a:lstStyle/>
@@ -3737,7 +3689,7 @@
           <a:noFill/>
         </p:spPr>
         <p:txBody>
-          <a:bodyPr wrap="square" anchor="t" lIns="0" rIns="0" tIns="0" bIns="0">
+          <a:bodyPr wrap="square" lIns="0" tIns="0" rIns="0" bIns="0" anchor="t">
             <a:spAutoFit/>
           </a:bodyPr>
           <a:lstStyle/>
@@ -3791,7 +3743,7 @@
           </a:fontRef>
         </p:style>
         <p:txBody>
-          <a:bodyPr rtlCol="0" anchor="ctr" lIns="228600"/>
+          <a:bodyPr lIns="228600" rtlCol="0" anchor="ctr"/>
           <a:lstStyle/>
           <a:p>
             <a:pPr algn="ctr"/>
@@ -3824,7 +3776,7 @@
           <a:noFill/>
         </p:spPr>
         <p:txBody>
-          <a:bodyPr wrap="square" anchor="ctr" lIns="0" rIns="0" tIns="0" bIns="0">
+          <a:bodyPr wrap="square" lIns="0" tIns="0" rIns="0" bIns="0" anchor="ctr">
             <a:spAutoFit/>
           </a:bodyPr>
           <a:lstStyle/>
@@ -3967,7 +3919,7 @@
           <a:noFill/>
         </p:spPr>
         <p:txBody>
-          <a:bodyPr wrap="square" anchor="t" lIns="0" rIns="0" tIns="0" bIns="0">
+          <a:bodyPr wrap="square" lIns="0" tIns="0" rIns="0" bIns="0" anchor="t">
             <a:spAutoFit/>
           </a:bodyPr>
           <a:lstStyle/>
@@ -3998,7 +3950,7 @@
 </file>
 
 <file path=ppt/slides/slide4.xml><?xml version="1.0" encoding="utf-8"?>
-<p:sld xmlns:a="http://schemas.openxmlformats.org/drawingml/2006/main" xmlns:p="http://schemas.openxmlformats.org/presentationml/2006/main" xmlns:r="http://schemas.openxmlformats.org/officeDocument/2006/relationships">
+<p:sld xmlns:a="http://schemas.openxmlformats.org/drawingml/2006/main" xmlns:r="http://schemas.openxmlformats.org/officeDocument/2006/relationships" xmlns:p="http://schemas.openxmlformats.org/presentationml/2006/main">
   <p:cSld>
     <p:spTree>
       <p:nvGrpSpPr>
@@ -4006,7 +3958,14 @@
         <p:cNvGrpSpPr/>
         <p:nvPr/>
       </p:nvGrpSpPr>
-      <p:grpSpPr/>
+      <p:grpSpPr>
+        <a:xfrm>
+          <a:off x="0" y="0"/>
+          <a:ext cx="0" cy="0"/>
+          <a:chOff x="0" y="0"/>
+          <a:chExt cx="0" cy="0"/>
+        </a:xfrm>
+      </p:grpSpPr>
       <p:sp>
         <p:nvSpPr>
           <p:cNvPr id="2" name="Rectangle 1"/>
@@ -4047,6 +4006,7 @@
           <a:lstStyle/>
           <a:p>
             <a:pPr algn="ctr"/>
+            <a:endParaRPr/>
           </a:p>
         </p:txBody>
       </p:sp>
@@ -4067,14 +4027,14 @@
           <a:noFill/>
         </p:spPr>
         <p:txBody>
-          <a:bodyPr wrap="square" anchor="t" lIns="0" rIns="0" tIns="0" bIns="0">
+          <a:bodyPr wrap="square" lIns="0" tIns="0" rIns="0" bIns="0" anchor="t">
             <a:spAutoFit/>
           </a:bodyPr>
           <a:lstStyle/>
           <a:p>
             <a:pPr algn="l"/>
             <a:r>
-              <a:rPr sz="1300" b="1" i="0" spc="220">
+              <a:rPr sz="1300" b="1" i="0" spc="220" dirty="0">
                 <a:solidFill>
                   <a:srgbClr val="C24E17"/>
                 </a:solidFill>
@@ -4102,7 +4062,7 @@
           <a:noFill/>
         </p:spPr>
         <p:txBody>
-          <a:bodyPr wrap="square" anchor="t" lIns="0" rIns="0" tIns="0" bIns="0">
+          <a:bodyPr wrap="square" lIns="0" tIns="0" rIns="0" bIns="0" anchor="t">
             <a:spAutoFit/>
           </a:bodyPr>
           <a:lstStyle/>
@@ -4176,6 +4136,7 @@
           <a:lstStyle/>
           <a:p>
             <a:pPr algn="ctr"/>
+            <a:endParaRPr/>
           </a:p>
         </p:txBody>
       </p:sp>
@@ -4196,7 +4157,7 @@
           <a:noFill/>
         </p:spPr>
         <p:txBody>
-          <a:bodyPr wrap="square" anchor="t" lIns="0" rIns="0" tIns="0" bIns="0">
+          <a:bodyPr wrap="square" lIns="0" tIns="0" rIns="0" bIns="0" anchor="t">
             <a:spAutoFit/>
           </a:bodyPr>
           <a:lstStyle/>
@@ -4270,6 +4231,7 @@
           <a:lstStyle/>
           <a:p>
             <a:pPr algn="ctr"/>
+            <a:endParaRPr/>
           </a:p>
         </p:txBody>
       </p:sp>
@@ -4290,7 +4252,7 @@
           <a:noFill/>
         </p:spPr>
         <p:txBody>
-          <a:bodyPr wrap="square" anchor="t" lIns="0" rIns="0" tIns="0" bIns="0">
+          <a:bodyPr wrap="square" lIns="0" tIns="0" rIns="0" bIns="0" anchor="t">
             <a:spAutoFit/>
           </a:bodyPr>
           <a:lstStyle/>
@@ -4364,6 +4326,7 @@
           <a:lstStyle/>
           <a:p>
             <a:pPr algn="ctr"/>
+            <a:endParaRPr/>
           </a:p>
         </p:txBody>
       </p:sp>
@@ -4384,7 +4347,7 @@
           <a:noFill/>
         </p:spPr>
         <p:txBody>
-          <a:bodyPr wrap="square" anchor="t" lIns="0" rIns="0" tIns="0" bIns="0">
+          <a:bodyPr wrap="square" lIns="0" tIns="0" rIns="0" bIns="0" anchor="t">
             <a:spAutoFit/>
           </a:bodyPr>
           <a:lstStyle/>
@@ -4458,6 +4421,7 @@
           <a:lstStyle/>
           <a:p>
             <a:pPr algn="ctr"/>
+            <a:endParaRPr/>
           </a:p>
         </p:txBody>
       </p:sp>
@@ -4478,7 +4442,7 @@
           <a:noFill/>
         </p:spPr>
         <p:txBody>
-          <a:bodyPr wrap="square" anchor="t" lIns="0" rIns="0" tIns="0" bIns="0">
+          <a:bodyPr wrap="square" lIns="0" tIns="0" rIns="0" bIns="0" anchor="t">
             <a:spAutoFit/>
           </a:bodyPr>
           <a:lstStyle/>
@@ -4552,6 +4516,7 @@
           <a:lstStyle/>
           <a:p>
             <a:pPr algn="ctr"/>
+            <a:endParaRPr/>
           </a:p>
         </p:txBody>
       </p:sp>
@@ -4572,7 +4537,7 @@
           <a:noFill/>
         </p:spPr>
         <p:txBody>
-          <a:bodyPr wrap="square" anchor="t" lIns="0" rIns="0" tIns="0" bIns="0">
+          <a:bodyPr wrap="square" lIns="0" tIns="0" rIns="0" bIns="0" anchor="t">
             <a:spAutoFit/>
           </a:bodyPr>
           <a:lstStyle/>
@@ -4646,6 +4611,7 @@
           <a:lstStyle/>
           <a:p>
             <a:pPr algn="ctr"/>
+            <a:endParaRPr/>
           </a:p>
         </p:txBody>
       </p:sp>
@@ -4666,7 +4632,7 @@
           <a:noFill/>
         </p:spPr>
         <p:txBody>
-          <a:bodyPr wrap="square" anchor="t" lIns="0" rIns="0" tIns="0" bIns="0">
+          <a:bodyPr wrap="square" lIns="0" tIns="0" rIns="0" bIns="0" anchor="t">
             <a:spAutoFit/>
           </a:bodyPr>
           <a:lstStyle/>
@@ -4709,7 +4675,7 @@
 </file>
 
 <file path=ppt/slides/slide5.xml><?xml version="1.0" encoding="utf-8"?>
-<p:sld xmlns:a="http://schemas.openxmlformats.org/drawingml/2006/main" xmlns:p="http://schemas.openxmlformats.org/presentationml/2006/main" xmlns:r="http://schemas.openxmlformats.org/officeDocument/2006/relationships">
+<p:sld xmlns:a="http://schemas.openxmlformats.org/drawingml/2006/main" xmlns:r="http://schemas.openxmlformats.org/officeDocument/2006/relationships" xmlns:p="http://schemas.openxmlformats.org/presentationml/2006/main">
   <p:cSld>
     <p:spTree>
       <p:nvGrpSpPr>
@@ -4717,7 +4683,14 @@
         <p:cNvGrpSpPr/>
         <p:nvPr/>
       </p:nvGrpSpPr>
-      <p:grpSpPr/>
+      <p:grpSpPr>
+        <a:xfrm>
+          <a:off x="0" y="0"/>
+          <a:ext cx="0" cy="0"/>
+          <a:chOff x="0" y="0"/>
+          <a:chExt cx="0" cy="0"/>
+        </a:xfrm>
+      </p:grpSpPr>
       <p:sp>
         <p:nvSpPr>
           <p:cNvPr id="2" name="Rectangle 1"/>
@@ -4758,6 +4731,7 @@
           <a:lstStyle/>
           <a:p>
             <a:pPr algn="ctr"/>
+            <a:endParaRPr/>
           </a:p>
         </p:txBody>
       </p:sp>
@@ -4778,7 +4752,7 @@
           <a:noFill/>
         </p:spPr>
         <p:txBody>
-          <a:bodyPr wrap="square" anchor="t" lIns="0" rIns="0" tIns="0" bIns="0">
+          <a:bodyPr wrap="square" lIns="0" tIns="0" rIns="0" bIns="0" anchor="t">
             <a:spAutoFit/>
           </a:bodyPr>
           <a:lstStyle/>
@@ -4813,7 +4787,7 @@
           <a:noFill/>
         </p:spPr>
         <p:txBody>
-          <a:bodyPr wrap="square" anchor="t" lIns="0" rIns="0" tIns="0" bIns="0">
+          <a:bodyPr wrap="square" lIns="0" tIns="0" rIns="0" bIns="0" anchor="t">
             <a:spAutoFit/>
           </a:bodyPr>
           <a:lstStyle/>
@@ -4848,7 +4822,7 @@
           <a:noFill/>
         </p:spPr>
         <p:txBody>
-          <a:bodyPr wrap="square" anchor="t" lIns="0" rIns="0" tIns="0" bIns="0">
+          <a:bodyPr wrap="square" lIns="0" tIns="0" rIns="0" bIns="0" anchor="t">
             <a:spAutoFit/>
           </a:bodyPr>
           <a:lstStyle/>
@@ -4912,6 +4886,7 @@
           <a:lstStyle/>
           <a:p>
             <a:pPr algn="ctr"/>
+            <a:endParaRPr/>
           </a:p>
         </p:txBody>
       </p:sp>
@@ -4955,6 +4930,7 @@
           <a:lstStyle/>
           <a:p>
             <a:pPr algn="ctr"/>
+            <a:endParaRPr/>
           </a:p>
         </p:txBody>
       </p:sp>
@@ -4998,6 +4974,7 @@
           <a:lstStyle/>
           <a:p>
             <a:pPr algn="ctr"/>
+            <a:endParaRPr/>
           </a:p>
         </p:txBody>
       </p:sp>
@@ -5041,6 +5018,7 @@
           <a:lstStyle/>
           <a:p>
             <a:pPr algn="ctr"/>
+            <a:endParaRPr/>
           </a:p>
         </p:txBody>
       </p:sp>
@@ -5084,6 +5062,7 @@
           <a:lstStyle/>
           <a:p>
             <a:pPr algn="ctr"/>
+            <a:endParaRPr/>
           </a:p>
         </p:txBody>
       </p:sp>
@@ -5104,7 +5083,7 @@
           <a:noFill/>
         </p:spPr>
         <p:txBody>
-          <a:bodyPr wrap="square" anchor="t" lIns="0" rIns="0" tIns="0" bIns="0">
+          <a:bodyPr wrap="square" lIns="0" tIns="0" rIns="0" bIns="0" anchor="t">
             <a:spAutoFit/>
           </a:bodyPr>
           <a:lstStyle/>
@@ -5162,6 +5141,7 @@
           <a:lstStyle/>
           <a:p>
             <a:pPr algn="ctr"/>
+            <a:endParaRPr/>
           </a:p>
         </p:txBody>
       </p:sp>
@@ -5182,7 +5162,7 @@
           <a:noFill/>
         </p:spPr>
         <p:txBody>
-          <a:bodyPr wrap="square" anchor="ctr" lIns="0" rIns="0" tIns="0" bIns="0">
+          <a:bodyPr wrap="square" lIns="0" tIns="0" rIns="0" bIns="0" anchor="ctr">
             <a:spAutoFit/>
           </a:bodyPr>
           <a:lstStyle/>
@@ -5240,6 +5220,7 @@
           <a:lstStyle/>
           <a:p>
             <a:pPr algn="ctr"/>
+            <a:endParaRPr/>
           </a:p>
         </p:txBody>
       </p:sp>
@@ -5283,6 +5264,7 @@
           <a:lstStyle/>
           <a:p>
             <a:pPr algn="ctr"/>
+            <a:endParaRPr/>
           </a:p>
         </p:txBody>
       </p:sp>
@@ -5303,7 +5285,7 @@
           <a:noFill/>
         </p:spPr>
         <p:txBody>
-          <a:bodyPr wrap="square" anchor="ctr" lIns="0" rIns="0" tIns="0" bIns="0">
+          <a:bodyPr wrap="square" lIns="0" tIns="0" rIns="0" bIns="0" anchor="ctr">
             <a:spAutoFit/>
           </a:bodyPr>
           <a:lstStyle/>
@@ -5338,7 +5320,7 @@
           <a:noFill/>
         </p:spPr>
         <p:txBody>
-          <a:bodyPr wrap="square" anchor="ctr" lIns="0" rIns="0" tIns="0" bIns="0">
+          <a:bodyPr wrap="square" lIns="0" tIns="0" rIns="0" bIns="0" anchor="ctr">
             <a:spAutoFit/>
           </a:bodyPr>
           <a:lstStyle/>
@@ -5373,7 +5355,7 @@
           <a:noFill/>
         </p:spPr>
         <p:txBody>
-          <a:bodyPr wrap="square" anchor="ctr" lIns="0" rIns="0" tIns="0" bIns="0">
+          <a:bodyPr wrap="square" lIns="0" tIns="0" rIns="0" bIns="0" anchor="ctr">
             <a:spAutoFit/>
           </a:bodyPr>
           <a:lstStyle/>
@@ -5408,7 +5390,7 @@
           <a:noFill/>
         </p:spPr>
         <p:txBody>
-          <a:bodyPr wrap="square" anchor="ctr" lIns="0" rIns="0" tIns="0" bIns="0">
+          <a:bodyPr wrap="square" lIns="0" tIns="0" rIns="0" bIns="0" anchor="ctr">
             <a:spAutoFit/>
           </a:bodyPr>
           <a:lstStyle/>
@@ -5443,7 +5425,7 @@
           <a:noFill/>
         </p:spPr>
         <p:txBody>
-          <a:bodyPr wrap="square" anchor="ctr" lIns="0" rIns="0" tIns="0" bIns="0">
+          <a:bodyPr wrap="square" lIns="0" tIns="0" rIns="0" bIns="0" anchor="ctr">
             <a:spAutoFit/>
           </a:bodyPr>
           <a:lstStyle/>
@@ -5478,7 +5460,7 @@
           <a:noFill/>
         </p:spPr>
         <p:txBody>
-          <a:bodyPr wrap="square" anchor="t" lIns="0" rIns="0" tIns="0" bIns="0">
+          <a:bodyPr wrap="square" lIns="0" tIns="0" rIns="0" bIns="0" anchor="t">
             <a:spAutoFit/>
           </a:bodyPr>
           <a:lstStyle/>
@@ -5538,6 +5520,7 @@
           <a:lstStyle/>
           <a:p>
             <a:pPr algn="ctr"/>
+            <a:endParaRPr/>
           </a:p>
         </p:txBody>
       </p:sp>
@@ -5558,7 +5541,7 @@
           <a:noFill/>
         </p:spPr>
         <p:txBody>
-          <a:bodyPr wrap="square" anchor="t" lIns="0" rIns="0" tIns="0" bIns="0">
+          <a:bodyPr wrap="square" lIns="0" tIns="0" rIns="0" bIns="0" anchor="t">
             <a:spAutoFit/>
           </a:bodyPr>
           <a:lstStyle/>
@@ -5647,7 +5630,7 @@
           <a:noFill/>
         </p:spPr>
         <p:txBody>
-          <a:bodyPr wrap="square" anchor="ctr" lIns="0" rIns="0" tIns="0" bIns="0">
+          <a:bodyPr wrap="square" lIns="0" tIns="0" rIns="0" bIns="0" anchor="ctr">
             <a:spAutoFit/>
           </a:bodyPr>
           <a:lstStyle/>
@@ -5703,7 +5686,7 @@
           </a:fontRef>
         </p:style>
         <p:txBody>
-          <a:bodyPr rtlCol="0" anchor="ctr" tIns="0" bIns="0" lIns="76200" rIns="76200"/>
+          <a:bodyPr lIns="76200" tIns="0" rIns="76200" bIns="0" rtlCol="0" anchor="ctr"/>
           <a:lstStyle/>
           <a:p>
             <a:pPr algn="ctr"/>
@@ -5736,7 +5719,7 @@
           <a:noFill/>
         </p:spPr>
         <p:txBody>
-          <a:bodyPr wrap="square" anchor="ctr" lIns="0" rIns="0" tIns="0" bIns="0">
+          <a:bodyPr wrap="square" lIns="0" tIns="0" rIns="0" bIns="0" anchor="ctr">
             <a:spAutoFit/>
           </a:bodyPr>
           <a:lstStyle/>
@@ -5792,7 +5775,7 @@
           </a:fontRef>
         </p:style>
         <p:txBody>
-          <a:bodyPr rtlCol="0" anchor="ctr" tIns="0" bIns="0" lIns="76200" rIns="76200"/>
+          <a:bodyPr lIns="76200" tIns="0" rIns="76200" bIns="0" rtlCol="0" anchor="ctr"/>
           <a:lstStyle/>
           <a:p>
             <a:pPr algn="ctr"/>
@@ -5825,7 +5808,7 @@
           <a:noFill/>
         </p:spPr>
         <p:txBody>
-          <a:bodyPr wrap="square" anchor="ctr" lIns="0" rIns="0" tIns="0" bIns="0">
+          <a:bodyPr wrap="square" lIns="0" tIns="0" rIns="0" bIns="0" anchor="ctr">
             <a:spAutoFit/>
           </a:bodyPr>
           <a:lstStyle/>
@@ -5881,7 +5864,7 @@
           </a:fontRef>
         </p:style>
         <p:txBody>
-          <a:bodyPr rtlCol="0" anchor="ctr" tIns="0" bIns="0" lIns="76200" rIns="76200"/>
+          <a:bodyPr lIns="76200" tIns="0" rIns="76200" bIns="0" rtlCol="0" anchor="ctr"/>
           <a:lstStyle/>
           <a:p>
             <a:pPr algn="ctr"/>
@@ -5914,7 +5897,7 @@
           <a:noFill/>
         </p:spPr>
         <p:txBody>
-          <a:bodyPr wrap="square" anchor="ctr" lIns="0" rIns="0" tIns="0" bIns="0">
+          <a:bodyPr wrap="square" lIns="0" tIns="0" rIns="0" bIns="0" anchor="ctr">
             <a:spAutoFit/>
           </a:bodyPr>
           <a:lstStyle/>
@@ -5970,7 +5953,7 @@
           </a:fontRef>
         </p:style>
         <p:txBody>
-          <a:bodyPr rtlCol="0" anchor="ctr" tIns="0" bIns="0" lIns="76200" rIns="76200"/>
+          <a:bodyPr lIns="76200" tIns="0" rIns="76200" bIns="0" rtlCol="0" anchor="ctr"/>
           <a:lstStyle/>
           <a:p>
             <a:pPr algn="ctr"/>
@@ -6057,7 +6040,7 @@
           <a:noFill/>
         </p:spPr>
         <p:txBody>
-          <a:bodyPr wrap="square" anchor="ctr" lIns="0" rIns="0" tIns="0" bIns="0">
+          <a:bodyPr wrap="square" lIns="0" tIns="0" rIns="0" bIns="0" anchor="ctr">
             <a:spAutoFit/>
           </a:bodyPr>
           <a:lstStyle/>
@@ -6092,7 +6075,7 @@
           <a:noFill/>
         </p:spPr>
         <p:txBody>
-          <a:bodyPr wrap="square" anchor="t" lIns="0" rIns="0" tIns="0" bIns="0">
+          <a:bodyPr wrap="square" lIns="0" tIns="0" rIns="0" bIns="0" anchor="t">
             <a:spAutoFit/>
           </a:bodyPr>
           <a:lstStyle/>
@@ -6150,6 +6133,7 @@
           <a:lstStyle/>
           <a:p>
             <a:pPr algn="ctr"/>
+            <a:endParaRPr/>
           </a:p>
         </p:txBody>
       </p:sp>
@@ -6170,7 +6154,7 @@
           <a:noFill/>
         </p:spPr>
         <p:txBody>
-          <a:bodyPr wrap="square" anchor="t" lIns="0" rIns="0" tIns="0" bIns="0">
+          <a:bodyPr wrap="square" lIns="0" tIns="0" rIns="0" bIns="0" anchor="t">
             <a:spAutoFit/>
           </a:bodyPr>
           <a:lstStyle/>
@@ -6232,6 +6216,7 @@
           <a:lstStyle/>
           <a:p>
             <a:pPr algn="ctr"/>
+            <a:endParaRPr/>
           </a:p>
         </p:txBody>
       </p:sp>
@@ -6252,7 +6237,7 @@
           <a:noFill/>
         </p:spPr>
         <p:txBody>
-          <a:bodyPr wrap="square" anchor="t" lIns="0" rIns="0" tIns="0" bIns="0">
+          <a:bodyPr wrap="square" lIns="0" tIns="0" rIns="0" bIns="0" anchor="t">
             <a:spAutoFit/>
           </a:bodyPr>
           <a:lstStyle/>
@@ -6314,6 +6299,7 @@
           <a:lstStyle/>
           <a:p>
             <a:pPr algn="ctr"/>
+            <a:endParaRPr/>
           </a:p>
         </p:txBody>
       </p:sp>
@@ -6334,7 +6320,7 @@
           <a:noFill/>
         </p:spPr>
         <p:txBody>
-          <a:bodyPr wrap="square" anchor="t" lIns="0" rIns="0" tIns="0" bIns="0">
+          <a:bodyPr wrap="square" lIns="0" tIns="0" rIns="0" bIns="0" anchor="t">
             <a:spAutoFit/>
           </a:bodyPr>
           <a:lstStyle/>
@@ -6396,6 +6382,7 @@
           <a:lstStyle/>
           <a:p>
             <a:pPr algn="ctr"/>
+            <a:endParaRPr/>
           </a:p>
         </p:txBody>
       </p:sp>
@@ -6416,7 +6403,7 @@
           <a:noFill/>
         </p:spPr>
         <p:txBody>
-          <a:bodyPr wrap="square" anchor="t" lIns="0" rIns="0" tIns="0" bIns="0">
+          <a:bodyPr wrap="square" lIns="0" tIns="0" rIns="0" bIns="0" anchor="t">
             <a:spAutoFit/>
           </a:bodyPr>
           <a:lstStyle/>
@@ -6478,6 +6465,7 @@
           <a:lstStyle/>
           <a:p>
             <a:pPr algn="ctr"/>
+            <a:endParaRPr/>
           </a:p>
         </p:txBody>
       </p:sp>
@@ -6521,6 +6509,7 @@
           <a:lstStyle/>
           <a:p>
             <a:pPr algn="ctr"/>
+            <a:endParaRPr/>
           </a:p>
         </p:txBody>
       </p:sp>
@@ -6541,7 +6530,7 @@
           <a:noFill/>
         </p:spPr>
         <p:txBody>
-          <a:bodyPr wrap="square" anchor="t" lIns="0" rIns="0" tIns="0" bIns="0">
+          <a:bodyPr wrap="square" lIns="0" tIns="0" rIns="0" bIns="0" anchor="t">
             <a:spAutoFit/>
           </a:bodyPr>
           <a:lstStyle/>
@@ -6572,7 +6561,7 @@
 </file>
 
 <file path=ppt/slides/slide6.xml><?xml version="1.0" encoding="utf-8"?>
-<p:sld xmlns:a="http://schemas.openxmlformats.org/drawingml/2006/main" xmlns:p="http://schemas.openxmlformats.org/presentationml/2006/main" xmlns:r="http://schemas.openxmlformats.org/officeDocument/2006/relationships">
+<p:sld xmlns:a="http://schemas.openxmlformats.org/drawingml/2006/main" xmlns:r="http://schemas.openxmlformats.org/officeDocument/2006/relationships" xmlns:p="http://schemas.openxmlformats.org/presentationml/2006/main">
   <p:cSld>
     <p:spTree>
       <p:nvGrpSpPr>
@@ -6580,7 +6569,14 @@
         <p:cNvGrpSpPr/>
         <p:nvPr/>
       </p:nvGrpSpPr>
-      <p:grpSpPr/>
+      <p:grpSpPr>
+        <a:xfrm>
+          <a:off x="0" y="0"/>
+          <a:ext cx="0" cy="0"/>
+          <a:chOff x="0" y="0"/>
+          <a:chExt cx="0" cy="0"/>
+        </a:xfrm>
+      </p:grpSpPr>
       <p:sp>
         <p:nvSpPr>
           <p:cNvPr id="2" name="Rectangle 1"/>
@@ -6621,6 +6617,7 @@
           <a:lstStyle/>
           <a:p>
             <a:pPr algn="ctr"/>
+            <a:endParaRPr/>
           </a:p>
         </p:txBody>
       </p:sp>
@@ -6641,7 +6638,7 @@
           <a:noFill/>
         </p:spPr>
         <p:txBody>
-          <a:bodyPr wrap="square" anchor="t" lIns="0" rIns="0" tIns="0" bIns="0">
+          <a:bodyPr wrap="square" lIns="0" tIns="0" rIns="0" bIns="0" anchor="t">
             <a:spAutoFit/>
           </a:bodyPr>
           <a:lstStyle/>
@@ -6676,7 +6673,7 @@
           <a:noFill/>
         </p:spPr>
         <p:txBody>
-          <a:bodyPr wrap="square" anchor="t" lIns="0" rIns="0" tIns="0" bIns="0">
+          <a:bodyPr wrap="square" lIns="0" tIns="0" rIns="0" bIns="0" anchor="t">
             <a:spAutoFit/>
           </a:bodyPr>
           <a:lstStyle/>
@@ -6711,7 +6708,7 @@
           <a:noFill/>
         </p:spPr>
         <p:txBody>
-          <a:bodyPr wrap="square" anchor="t" lIns="0" rIns="0" tIns="0" bIns="0">
+          <a:bodyPr wrap="square" lIns="0" tIns="0" rIns="0" bIns="0" anchor="t">
             <a:spAutoFit/>
           </a:bodyPr>
           <a:lstStyle/>
@@ -6746,7 +6743,7 @@
           <a:noFill/>
         </p:spPr>
         <p:txBody>
-          <a:bodyPr wrap="square" anchor="t" lIns="0" rIns="0" tIns="0" bIns="0">
+          <a:bodyPr wrap="square" lIns="0" tIns="0" rIns="0" bIns="0" anchor="t">
             <a:spAutoFit/>
           </a:bodyPr>
           <a:lstStyle/>
@@ -6797,7 +6794,7 @@
           <a:noFill/>
         </p:spPr>
         <p:txBody>
-          <a:bodyPr wrap="square" anchor="t" lIns="0" rIns="0" tIns="0" bIns="0">
+          <a:bodyPr wrap="square" lIns="0" tIns="0" rIns="0" bIns="0" anchor="t">
             <a:spAutoFit/>
           </a:bodyPr>
           <a:lstStyle/>
@@ -6832,7 +6829,7 @@
           <a:noFill/>
         </p:spPr>
         <p:txBody>
-          <a:bodyPr wrap="square" anchor="t" lIns="0" rIns="0" tIns="0" bIns="0">
+          <a:bodyPr wrap="square" lIns="0" tIns="0" rIns="0" bIns="0" anchor="t">
             <a:spAutoFit/>
           </a:bodyPr>
           <a:lstStyle/>
@@ -6883,7 +6880,7 @@
           <a:noFill/>
         </p:spPr>
         <p:txBody>
-          <a:bodyPr wrap="square" anchor="t" lIns="0" rIns="0" tIns="0" bIns="0">
+          <a:bodyPr wrap="square" lIns="0" tIns="0" rIns="0" bIns="0" anchor="t">
             <a:spAutoFit/>
           </a:bodyPr>
           <a:lstStyle/>
@@ -6918,7 +6915,7 @@
           <a:noFill/>
         </p:spPr>
         <p:txBody>
-          <a:bodyPr wrap="square" anchor="t" lIns="0" rIns="0" tIns="0" bIns="0">
+          <a:bodyPr wrap="square" lIns="0" tIns="0" rIns="0" bIns="0" anchor="t">
             <a:spAutoFit/>
           </a:bodyPr>
           <a:lstStyle/>
@@ -6961,7 +6958,7 @@
 </file>
 
 <file path=ppt/slides/slide7.xml><?xml version="1.0" encoding="utf-8"?>
-<p:sld xmlns:a="http://schemas.openxmlformats.org/drawingml/2006/main" xmlns:p="http://schemas.openxmlformats.org/presentationml/2006/main" xmlns:r="http://schemas.openxmlformats.org/officeDocument/2006/relationships">
+<p:sld xmlns:a="http://schemas.openxmlformats.org/drawingml/2006/main" xmlns:r="http://schemas.openxmlformats.org/officeDocument/2006/relationships" xmlns:p="http://schemas.openxmlformats.org/presentationml/2006/main">
   <p:cSld>
     <p:spTree>
       <p:nvGrpSpPr>
@@ -6969,7 +6966,14 @@
         <p:cNvGrpSpPr/>
         <p:nvPr/>
       </p:nvGrpSpPr>
-      <p:grpSpPr/>
+      <p:grpSpPr>
+        <a:xfrm>
+          <a:off x="0" y="0"/>
+          <a:ext cx="0" cy="0"/>
+          <a:chOff x="0" y="0"/>
+          <a:chExt cx="0" cy="0"/>
+        </a:xfrm>
+      </p:grpSpPr>
       <p:sp>
         <p:nvSpPr>
           <p:cNvPr id="2" name="Rectangle 1"/>
@@ -6978,7 +6982,7 @@
         </p:nvSpPr>
         <p:spPr>
           <a:xfrm>
-            <a:off x="0" y="0"/>
+            <a:off x="0" y="291752"/>
             <a:ext cx="12191695" cy="6858000"/>
           </a:xfrm>
           <a:prstGeom prst="rect">
@@ -7010,19 +7014,20 @@
           <a:lstStyle/>
           <a:p>
             <a:pPr algn="ctr"/>
-          </a:p>
-        </p:txBody>
-      </p:sp>
-      <p:sp>
-        <p:nvSpPr>
-          <p:cNvPr id="3" name="TextBox 2"/>
+            <a:endParaRPr/>
+          </a:p>
+        </p:txBody>
+      </p:sp>
+      <p:sp>
+        <p:nvSpPr>
+          <p:cNvPr id="4" name="TextBox 3"/>
           <p:cNvSpPr txBox="1"/>
           <p:nvPr/>
         </p:nvSpPr>
         <p:spPr>
           <a:xfrm>
-            <a:off x="822960" y="640080"/>
-            <a:ext cx="10058400" cy="365760"/>
+            <a:off x="777240" y="1143000"/>
+            <a:ext cx="10607040" cy="461665"/>
           </a:xfrm>
           <a:prstGeom prst="rect">
             <a:avLst/>
@@ -7030,232 +7035,54 @@
           <a:noFill/>
         </p:spPr>
         <p:txBody>
-          <a:bodyPr wrap="square" anchor="t" lIns="0" rIns="0" tIns="0" bIns="0">
+          <a:bodyPr wrap="square" lIns="0" tIns="0" rIns="0" bIns="0" anchor="t">
             <a:spAutoFit/>
           </a:bodyPr>
           <a:lstStyle/>
           <a:p>
             <a:pPr algn="l"/>
             <a:r>
-              <a:rPr sz="1300" b="1" i="0" spc="220">
-                <a:solidFill>
-                  <a:srgbClr val="C24E17"/>
+              <a:rPr lang="en-US" sz="3000" b="1" i="0" dirty="0">
+                <a:solidFill>
+                  <a:srgbClr val="261D17"/>
                 </a:solidFill>
                 <a:latin typeface="Arial"/>
               </a:rPr>
-              <a:t>WHO WOULD BUILD WITH IT</a:t>
-            </a:r>
-          </a:p>
-        </p:txBody>
-      </p:sp>
-      <p:sp>
-        <p:nvSpPr>
-          <p:cNvPr id="4" name="TextBox 3"/>
-          <p:cNvSpPr txBox="1"/>
-          <p:nvPr/>
-        </p:nvSpPr>
-        <p:spPr>
-          <a:xfrm>
-            <a:off x="777240" y="1143000"/>
-            <a:ext cx="10607040" cy="640080"/>
-          </a:xfrm>
-          <a:prstGeom prst="rect">
-            <a:avLst/>
-          </a:prstGeom>
-          <a:noFill/>
-        </p:spPr>
-        <p:txBody>
-          <a:bodyPr wrap="square" anchor="t" lIns="0" rIns="0" tIns="0" bIns="0">
-            <a:spAutoFit/>
-          </a:bodyPr>
-          <a:lstStyle/>
-          <a:p>
-            <a:pPr algn="l"/>
-            <a:r>
-              <a:rPr sz="3000" b="1" i="0">
+              <a:t>How </a:t>
+            </a:r>
+            <a:r>
+              <a:rPr sz="3000" b="1" i="0" dirty="0" err="1">
                 <a:solidFill>
                   <a:srgbClr val="261D17"/>
                 </a:solidFill>
                 <a:latin typeface="Arial"/>
               </a:rPr>
-              <a:t>Six apps, and how PingIt helps.</a:t>
-            </a:r>
-          </a:p>
-        </p:txBody>
-      </p:sp>
-      <p:sp>
-        <p:nvSpPr>
-          <p:cNvPr id="5" name="Rounded Rectangle 4"/>
-          <p:cNvSpPr/>
-          <p:nvPr/>
-        </p:nvSpPr>
-        <p:spPr>
-          <a:xfrm>
-            <a:off x="868680" y="2011680"/>
-            <a:ext cx="676656" cy="676656"/>
-          </a:xfrm>
-          <a:prstGeom prst="roundRect">
-            <a:avLst>
-              <a:gd name="adj" fmla="val 30000"/>
-            </a:avLst>
-          </a:prstGeom>
-          <a:solidFill>
-            <a:srgbClr val="C13584"/>
-          </a:solidFill>
-          <a:ln>
-            <a:noFill/>
-          </a:ln>
-        </p:spPr>
-        <p:style>
-          <a:lnRef idx="1">
-            <a:schemeClr val="accent1"/>
-          </a:lnRef>
-          <a:fillRef idx="3">
-            <a:schemeClr val="accent1"/>
-          </a:fillRef>
-          <a:effectRef idx="2">
-            <a:schemeClr val="accent1"/>
-          </a:effectRef>
-          <a:fontRef idx="minor">
-            <a:schemeClr val="lt1"/>
-          </a:fontRef>
-        </p:style>
-        <p:txBody>
-          <a:bodyPr rtlCol="0" anchor="ctr"/>
-          <a:lstStyle/>
-          <a:p>
-            <a:pPr algn="ctr"/>
-          </a:p>
-        </p:txBody>
-      </p:sp>
-      <p:sp>
-        <p:nvSpPr>
-          <p:cNvPr id="6" name="Rounded Rectangle 5"/>
-          <p:cNvSpPr/>
-          <p:nvPr/>
-        </p:nvSpPr>
-        <p:spPr>
-          <a:xfrm>
-            <a:off x="1004011" y="2201143"/>
-            <a:ext cx="405993" cy="297728"/>
-          </a:xfrm>
-          <a:prstGeom prst="roundRect">
-            <a:avLst>
-              <a:gd name="adj" fmla="val 30000"/>
-            </a:avLst>
-          </a:prstGeom>
-          <a:noFill/>
-          <a:ln w="27940">
-            <a:solidFill>
-              <a:srgbClr val="FFFFFF"/>
-            </a:solidFill>
-          </a:ln>
-        </p:spPr>
-        <p:style>
-          <a:lnRef idx="1">
-            <a:schemeClr val="accent1"/>
-          </a:lnRef>
-          <a:fillRef idx="3">
-            <a:schemeClr val="accent1"/>
-          </a:fillRef>
-          <a:effectRef idx="2">
-            <a:schemeClr val="accent1"/>
-          </a:effectRef>
-          <a:fontRef idx="minor">
-            <a:schemeClr val="lt1"/>
-          </a:fontRef>
-        </p:style>
-        <p:txBody>
-          <a:bodyPr rtlCol="0" anchor="ctr"/>
-          <a:lstStyle/>
-          <a:p>
-            <a:pPr algn="ctr"/>
-          </a:p>
-        </p:txBody>
-      </p:sp>
-      <p:sp>
-        <p:nvSpPr>
-          <p:cNvPr id="7" name="Oval 6"/>
-          <p:cNvSpPr/>
-          <p:nvPr/>
-        </p:nvSpPr>
-        <p:spPr>
-          <a:xfrm>
-            <a:off x="1119042" y="2282342"/>
-            <a:ext cx="175930" cy="175930"/>
-          </a:xfrm>
-          <a:prstGeom prst="ellipse">
-            <a:avLst/>
-          </a:prstGeom>
-          <a:noFill/>
-          <a:ln w="27940">
-            <a:solidFill>
-              <a:srgbClr val="FFFFFF"/>
-            </a:solidFill>
-          </a:ln>
-        </p:spPr>
-        <p:style>
-          <a:lnRef idx="1">
-            <a:schemeClr val="accent1"/>
-          </a:lnRef>
-          <a:fillRef idx="3">
-            <a:schemeClr val="accent1"/>
-          </a:fillRef>
-          <a:effectRef idx="2">
-            <a:schemeClr val="accent1"/>
-          </a:effectRef>
-          <a:fontRef idx="minor">
-            <a:schemeClr val="lt1"/>
-          </a:fontRef>
-        </p:style>
-        <p:txBody>
-          <a:bodyPr rtlCol="0" anchor="ctr"/>
-          <a:lstStyle/>
-          <a:p>
-            <a:pPr algn="ctr"/>
-          </a:p>
-        </p:txBody>
-      </p:sp>
-      <p:sp>
-        <p:nvSpPr>
-          <p:cNvPr id="8" name="Oval 7"/>
-          <p:cNvSpPr/>
-          <p:nvPr/>
-        </p:nvSpPr>
-        <p:spPr>
-          <a:xfrm>
-            <a:off x="1288206" y="2228209"/>
-            <a:ext cx="60899" cy="60899"/>
-          </a:xfrm>
-          <a:prstGeom prst="ellipse">
-            <a:avLst/>
-          </a:prstGeom>
-          <a:solidFill>
-            <a:srgbClr val="FFFFFF"/>
-          </a:solidFill>
-          <a:ln>
-            <a:noFill/>
-          </a:ln>
-        </p:spPr>
-        <p:style>
-          <a:lnRef idx="1">
-            <a:schemeClr val="accent1"/>
-          </a:lnRef>
-          <a:fillRef idx="3">
-            <a:schemeClr val="accent1"/>
-          </a:fillRef>
-          <a:effectRef idx="2">
-            <a:schemeClr val="accent1"/>
-          </a:effectRef>
-          <a:fontRef idx="minor">
-            <a:schemeClr val="lt1"/>
-          </a:fontRef>
-        </p:style>
-        <p:txBody>
-          <a:bodyPr rtlCol="0" anchor="ctr"/>
-          <a:lstStyle/>
-          <a:p>
-            <a:pPr algn="ctr"/>
+              <a:t>PingIt</a:t>
+            </a:r>
+            <a:r>
+              <a:rPr sz="3000" b="1" i="0" dirty="0">
+                <a:solidFill>
+                  <a:srgbClr val="261D17"/>
+                </a:solidFill>
+                <a:latin typeface="Arial"/>
+              </a:rPr>
+              <a:t> helps</a:t>
+            </a:r>
+            <a:r>
+              <a:rPr lang="en-US" sz="3000" b="1" i="0" dirty="0">
+                <a:solidFill>
+                  <a:srgbClr val="261D17"/>
+                </a:solidFill>
+                <a:latin typeface="Arial"/>
+              </a:rPr>
+              <a:t>?</a:t>
+            </a:r>
+            <a:endParaRPr sz="3000" b="1" i="0" dirty="0">
+              <a:solidFill>
+                <a:srgbClr val="261D17"/>
+              </a:solidFill>
+              <a:latin typeface="Arial"/>
+            </a:endParaRPr>
           </a:p>
         </p:txBody>
       </p:sp>
@@ -7276,7 +7103,7 @@
           <a:noFill/>
         </p:spPr>
         <p:txBody>
-          <a:bodyPr wrap="square" anchor="t" lIns="0" rIns="0" tIns="0" bIns="0">
+          <a:bodyPr wrap="square" lIns="0" tIns="0" rIns="0" bIns="0" anchor="t">
             <a:spAutoFit/>
           </a:bodyPr>
           <a:lstStyle/>
@@ -7287,7 +7114,7 @@
               </a:spcAft>
             </a:pPr>
             <a:r>
-              <a:rPr sz="1800" b="1" i="0">
+              <a:rPr sz="1800" b="1" i="0" dirty="0">
                 <a:solidFill>
                   <a:srgbClr val="261D17"/>
                 </a:solidFill>
@@ -7303,67 +7130,13 @@
               </a:lnSpc>
             </a:pPr>
             <a:r>
-              <a:rPr sz="1300" b="0" i="0">
+              <a:rPr sz="1300" b="0" i="0" dirty="0">
                 <a:solidFill>
                   <a:srgbClr val="8A7C6E"/>
                 </a:solidFill>
                 <a:latin typeface="Arial"/>
               </a:rPr>
               <a:t>Check before a big creator goes Live, so a shaky link never tanks the stream, or their reputation.</a:t>
-            </a:r>
-          </a:p>
-        </p:txBody>
-      </p:sp>
-      <p:sp>
-        <p:nvSpPr>
-          <p:cNvPr id="10" name="Rounded Rectangle 9"/>
-          <p:cNvSpPr/>
-          <p:nvPr/>
-        </p:nvSpPr>
-        <p:spPr>
-          <a:xfrm>
-            <a:off x="868680" y="3474720"/>
-            <a:ext cx="676656" cy="676656"/>
-          </a:xfrm>
-          <a:prstGeom prst="roundRect">
-            <a:avLst>
-              <a:gd name="adj" fmla="val 30000"/>
-            </a:avLst>
-          </a:prstGeom>
-          <a:solidFill>
-            <a:srgbClr val="141414"/>
-          </a:solidFill>
-          <a:ln>
-            <a:noFill/>
-          </a:ln>
-        </p:spPr>
-        <p:style>
-          <a:lnRef idx="1">
-            <a:schemeClr val="accent1"/>
-          </a:lnRef>
-          <a:fillRef idx="3">
-            <a:schemeClr val="accent1"/>
-          </a:fillRef>
-          <a:effectRef idx="2">
-            <a:schemeClr val="accent1"/>
-          </a:effectRef>
-          <a:fontRef idx="minor">
-            <a:schemeClr val="lt1"/>
-          </a:fontRef>
-        </p:style>
-        <p:txBody>
-          <a:bodyPr rtlCol="0" anchor="ctr" wrap="none" lIns="0" rIns="0" tIns="0" bIns="0"/>
-          <a:lstStyle/>
-          <a:p>
-            <a:pPr algn="ctr"/>
-            <a:r>
-              <a:rPr b="1" sz="3400">
-                <a:solidFill>
-                  <a:srgbClr val="E50914"/>
-                </a:solidFill>
-                <a:latin typeface="Arial"/>
-              </a:rPr>
-              <a:t>N</a:t>
             </a:r>
           </a:p>
         </p:txBody>
@@ -7385,7 +7158,7 @@
           <a:noFill/>
         </p:spPr>
         <p:txBody>
-          <a:bodyPr wrap="square" anchor="t" lIns="0" rIns="0" tIns="0" bIns="0">
+          <a:bodyPr wrap="square" lIns="0" tIns="0" rIns="0" bIns="0" anchor="t">
             <a:spAutoFit/>
           </a:bodyPr>
           <a:lstStyle/>
@@ -7425,94 +7198,6 @@
       </p:sp>
       <p:sp>
         <p:nvSpPr>
-          <p:cNvPr id="12" name="Rounded Rectangle 11"/>
-          <p:cNvSpPr/>
-          <p:nvPr/>
-        </p:nvSpPr>
-        <p:spPr>
-          <a:xfrm>
-            <a:off x="868680" y="4937760"/>
-            <a:ext cx="676656" cy="676656"/>
-          </a:xfrm>
-          <a:prstGeom prst="roundRect">
-            <a:avLst>
-              <a:gd name="adj" fmla="val 30000"/>
-            </a:avLst>
-          </a:prstGeom>
-          <a:solidFill>
-            <a:srgbClr val="25D366"/>
-          </a:solidFill>
-          <a:ln>
-            <a:noFill/>
-          </a:ln>
-        </p:spPr>
-        <p:style>
-          <a:lnRef idx="1">
-            <a:schemeClr val="accent1"/>
-          </a:lnRef>
-          <a:fillRef idx="3">
-            <a:schemeClr val="accent1"/>
-          </a:fillRef>
-          <a:effectRef idx="2">
-            <a:schemeClr val="accent1"/>
-          </a:effectRef>
-          <a:fontRef idx="minor">
-            <a:schemeClr val="lt1"/>
-          </a:fontRef>
-        </p:style>
-        <p:txBody>
-          <a:bodyPr rtlCol="0" anchor="ctr"/>
-          <a:lstStyle/>
-          <a:p>
-            <a:pPr algn="ctr"/>
-          </a:p>
-        </p:txBody>
-      </p:sp>
-      <p:sp>
-        <p:nvSpPr>
-          <p:cNvPr id="13" name="Oval Callout 12"/>
-          <p:cNvSpPr/>
-          <p:nvPr/>
-        </p:nvSpPr>
-        <p:spPr>
-          <a:xfrm>
-            <a:off x="990478" y="5046024"/>
-            <a:ext cx="419526" cy="351861"/>
-          </a:xfrm>
-          <a:prstGeom prst="wedgeEllipseCallout">
-            <a:avLst/>
-          </a:prstGeom>
-          <a:solidFill>
-            <a:srgbClr val="FFFFFF"/>
-          </a:solidFill>
-          <a:ln>
-            <a:noFill/>
-          </a:ln>
-        </p:spPr>
-        <p:style>
-          <a:lnRef idx="1">
-            <a:schemeClr val="accent1"/>
-          </a:lnRef>
-          <a:fillRef idx="3">
-            <a:schemeClr val="accent1"/>
-          </a:fillRef>
-          <a:effectRef idx="2">
-            <a:schemeClr val="accent1"/>
-          </a:effectRef>
-          <a:fontRef idx="minor">
-            <a:schemeClr val="lt1"/>
-          </a:fontRef>
-        </p:style>
-        <p:txBody>
-          <a:bodyPr rtlCol="0" anchor="ctr"/>
-          <a:lstStyle/>
-          <a:p>
-            <a:pPr algn="ctr"/>
-          </a:p>
-        </p:txBody>
-      </p:sp>
-      <p:sp>
-        <p:nvSpPr>
           <p:cNvPr id="14" name="TextBox 13"/>
           <p:cNvSpPr txBox="1"/>
           <p:nvPr/>
@@ -7528,7 +7213,7 @@
           <a:noFill/>
         </p:spPr>
         <p:txBody>
-          <a:bodyPr wrap="square" anchor="t" lIns="0" rIns="0" tIns="0" bIns="0">
+          <a:bodyPr wrap="square" lIns="0" tIns="0" rIns="0" bIns="0" anchor="t">
             <a:spAutoFit/>
           </a:bodyPr>
           <a:lstStyle/>
@@ -7568,225 +7253,6 @@
       </p:sp>
       <p:sp>
         <p:nvSpPr>
-          <p:cNvPr id="15" name="Rounded Rectangle 14"/>
-          <p:cNvSpPr/>
-          <p:nvPr/>
-        </p:nvSpPr>
-        <p:spPr>
-          <a:xfrm>
-            <a:off x="6583680" y="2011680"/>
-            <a:ext cx="676656" cy="676656"/>
-          </a:xfrm>
-          <a:prstGeom prst="roundRect">
-            <a:avLst>
-              <a:gd name="adj" fmla="val 30000"/>
-            </a:avLst>
-          </a:prstGeom>
-          <a:solidFill>
-            <a:srgbClr val="FFFFFF"/>
-          </a:solidFill>
-          <a:ln w="12700">
-            <a:solidFill>
-              <a:srgbClr val="DEDEDE"/>
-            </a:solidFill>
-          </a:ln>
-        </p:spPr>
-        <p:style>
-          <a:lnRef idx="1">
-            <a:schemeClr val="accent1"/>
-          </a:lnRef>
-          <a:fillRef idx="3">
-            <a:schemeClr val="accent1"/>
-          </a:fillRef>
-          <a:effectRef idx="2">
-            <a:schemeClr val="accent1"/>
-          </a:effectRef>
-          <a:fontRef idx="minor">
-            <a:schemeClr val="lt1"/>
-          </a:fontRef>
-        </p:style>
-        <p:txBody>
-          <a:bodyPr rtlCol="0" anchor="ctr"/>
-          <a:lstStyle/>
-          <a:p>
-            <a:pPr algn="ctr"/>
-          </a:p>
-        </p:txBody>
-      </p:sp>
-      <p:sp>
-        <p:nvSpPr>
-          <p:cNvPr id="16" name="Oval 15"/>
-          <p:cNvSpPr/>
-          <p:nvPr/>
-        </p:nvSpPr>
-        <p:spPr>
-          <a:xfrm>
-            <a:off x="6813743" y="2079345"/>
-            <a:ext cx="216529" cy="216529"/>
-          </a:xfrm>
-          <a:prstGeom prst="ellipse">
-            <a:avLst/>
-          </a:prstGeom>
-          <a:solidFill>
-            <a:srgbClr val="EA4335"/>
-          </a:solidFill>
-          <a:ln>
-            <a:noFill/>
-          </a:ln>
-        </p:spPr>
-        <p:style>
-          <a:lnRef idx="1">
-            <a:schemeClr val="accent1"/>
-          </a:lnRef>
-          <a:fillRef idx="3">
-            <a:schemeClr val="accent1"/>
-          </a:fillRef>
-          <a:effectRef idx="2">
-            <a:schemeClr val="accent1"/>
-          </a:effectRef>
-          <a:fontRef idx="minor">
-            <a:schemeClr val="lt1"/>
-          </a:fontRef>
-        </p:style>
-        <p:txBody>
-          <a:bodyPr rtlCol="0" anchor="ctr"/>
-          <a:lstStyle/>
-          <a:p>
-            <a:pPr algn="ctr"/>
-          </a:p>
-        </p:txBody>
-      </p:sp>
-      <p:sp>
-        <p:nvSpPr>
-          <p:cNvPr id="17" name="Oval 16"/>
-          <p:cNvSpPr/>
-          <p:nvPr/>
-        </p:nvSpPr>
-        <p:spPr>
-          <a:xfrm>
-            <a:off x="6962607" y="2241743"/>
-            <a:ext cx="216529" cy="216529"/>
-          </a:xfrm>
-          <a:prstGeom prst="ellipse">
-            <a:avLst/>
-          </a:prstGeom>
-          <a:solidFill>
-            <a:srgbClr val="FBBC05"/>
-          </a:solidFill>
-          <a:ln>
-            <a:noFill/>
-          </a:ln>
-        </p:spPr>
-        <p:style>
-          <a:lnRef idx="1">
-            <a:schemeClr val="accent1"/>
-          </a:lnRef>
-          <a:fillRef idx="3">
-            <a:schemeClr val="accent1"/>
-          </a:fillRef>
-          <a:effectRef idx="2">
-            <a:schemeClr val="accent1"/>
-          </a:effectRef>
-          <a:fontRef idx="minor">
-            <a:schemeClr val="lt1"/>
-          </a:fontRef>
-        </p:style>
-        <p:txBody>
-          <a:bodyPr rtlCol="0" anchor="ctr"/>
-          <a:lstStyle/>
-          <a:p>
-            <a:pPr algn="ctr"/>
-          </a:p>
-        </p:txBody>
-      </p:sp>
-      <p:sp>
-        <p:nvSpPr>
-          <p:cNvPr id="18" name="Oval 17"/>
-          <p:cNvSpPr/>
-          <p:nvPr/>
-        </p:nvSpPr>
-        <p:spPr>
-          <a:xfrm>
-            <a:off x="6813743" y="2390607"/>
-            <a:ext cx="216529" cy="216529"/>
-          </a:xfrm>
-          <a:prstGeom prst="ellipse">
-            <a:avLst/>
-          </a:prstGeom>
-          <a:solidFill>
-            <a:srgbClr val="34A853"/>
-          </a:solidFill>
-          <a:ln>
-            <a:noFill/>
-          </a:ln>
-        </p:spPr>
-        <p:style>
-          <a:lnRef idx="1">
-            <a:schemeClr val="accent1"/>
-          </a:lnRef>
-          <a:fillRef idx="3">
-            <a:schemeClr val="accent1"/>
-          </a:fillRef>
-          <a:effectRef idx="2">
-            <a:schemeClr val="accent1"/>
-          </a:effectRef>
-          <a:fontRef idx="minor">
-            <a:schemeClr val="lt1"/>
-          </a:fontRef>
-        </p:style>
-        <p:txBody>
-          <a:bodyPr rtlCol="0" anchor="ctr"/>
-          <a:lstStyle/>
-          <a:p>
-            <a:pPr algn="ctr"/>
-          </a:p>
-        </p:txBody>
-      </p:sp>
-      <p:sp>
-        <p:nvSpPr>
-          <p:cNvPr id="19" name="Oval 18"/>
-          <p:cNvSpPr/>
-          <p:nvPr/>
-        </p:nvSpPr>
-        <p:spPr>
-          <a:xfrm>
-            <a:off x="6664878" y="2241743"/>
-            <a:ext cx="216529" cy="216529"/>
-          </a:xfrm>
-          <a:prstGeom prst="ellipse">
-            <a:avLst/>
-          </a:prstGeom>
-          <a:solidFill>
-            <a:srgbClr val="4285F4"/>
-          </a:solidFill>
-          <a:ln>
-            <a:noFill/>
-          </a:ln>
-        </p:spPr>
-        <p:style>
-          <a:lnRef idx="1">
-            <a:schemeClr val="accent1"/>
-          </a:lnRef>
-          <a:fillRef idx="3">
-            <a:schemeClr val="accent1"/>
-          </a:fillRef>
-          <a:effectRef idx="2">
-            <a:schemeClr val="accent1"/>
-          </a:effectRef>
-          <a:fontRef idx="minor">
-            <a:schemeClr val="lt1"/>
-          </a:fontRef>
-        </p:style>
-        <p:txBody>
-          <a:bodyPr rtlCol="0" anchor="ctr"/>
-          <a:lstStyle/>
-          <a:p>
-            <a:pPr algn="ctr"/>
-          </a:p>
-        </p:txBody>
-      </p:sp>
-      <p:sp>
-        <p:nvSpPr>
           <p:cNvPr id="20" name="TextBox 19"/>
           <p:cNvSpPr txBox="1"/>
           <p:nvPr/>
@@ -7802,7 +7268,7 @@
           <a:noFill/>
         </p:spPr>
         <p:txBody>
-          <a:bodyPr wrap="square" anchor="t" lIns="0" rIns="0" tIns="0" bIns="0">
+          <a:bodyPr wrap="square" lIns="0" tIns="0" rIns="0" bIns="0" anchor="t">
             <a:spAutoFit/>
           </a:bodyPr>
           <a:lstStyle/>
@@ -7842,60 +7308,6 @@
       </p:sp>
       <p:sp>
         <p:nvSpPr>
-          <p:cNvPr id="21" name="Rounded Rectangle 20"/>
-          <p:cNvSpPr/>
-          <p:nvPr/>
-        </p:nvSpPr>
-        <p:spPr>
-          <a:xfrm>
-            <a:off x="6583680" y="3474720"/>
-            <a:ext cx="676656" cy="676656"/>
-          </a:xfrm>
-          <a:prstGeom prst="roundRect">
-            <a:avLst>
-              <a:gd name="adj" fmla="val 30000"/>
-            </a:avLst>
-          </a:prstGeom>
-          <a:solidFill>
-            <a:srgbClr val="107C10"/>
-          </a:solidFill>
-          <a:ln>
-            <a:noFill/>
-          </a:ln>
-        </p:spPr>
-        <p:style>
-          <a:lnRef idx="1">
-            <a:schemeClr val="accent1"/>
-          </a:lnRef>
-          <a:fillRef idx="3">
-            <a:schemeClr val="accent1"/>
-          </a:fillRef>
-          <a:effectRef idx="2">
-            <a:schemeClr val="accent1"/>
-          </a:effectRef>
-          <a:fontRef idx="minor">
-            <a:schemeClr val="lt1"/>
-          </a:fontRef>
-        </p:style>
-        <p:txBody>
-          <a:bodyPr rtlCol="0" anchor="ctr" wrap="none" lIns="0" rIns="0" tIns="0" bIns="0"/>
-          <a:lstStyle/>
-          <a:p>
-            <a:pPr algn="ctr"/>
-            <a:r>
-              <a:rPr b="1" sz="3200">
-                <a:solidFill>
-                  <a:srgbClr val="FFFFFF"/>
-                </a:solidFill>
-                <a:latin typeface="Arial"/>
-              </a:rPr>
-              <a:t>X</a:t>
-            </a:r>
-          </a:p>
-        </p:txBody>
-      </p:sp>
-      <p:sp>
-        <p:nvSpPr>
           <p:cNvPr id="22" name="TextBox 21"/>
           <p:cNvSpPr txBox="1"/>
           <p:nvPr/>
@@ -7911,7 +7323,7 @@
           <a:noFill/>
         </p:spPr>
         <p:txBody>
-          <a:bodyPr wrap="square" anchor="t" lIns="0" rIns="0" tIns="0" bIns="0">
+          <a:bodyPr wrap="square" lIns="0" tIns="0" rIns="0" bIns="0" anchor="t">
             <a:spAutoFit/>
           </a:bodyPr>
           <a:lstStyle/>
@@ -7951,60 +7363,6 @@
       </p:sp>
       <p:sp>
         <p:nvSpPr>
-          <p:cNvPr id="23" name="Rounded Rectangle 22"/>
-          <p:cNvSpPr/>
-          <p:nvPr/>
-        </p:nvSpPr>
-        <p:spPr>
-          <a:xfrm>
-            <a:off x="6583680" y="4937760"/>
-            <a:ext cx="676656" cy="676656"/>
-          </a:xfrm>
-          <a:prstGeom prst="roundRect">
-            <a:avLst>
-              <a:gd name="adj" fmla="val 30000"/>
-            </a:avLst>
-          </a:prstGeom>
-          <a:solidFill>
-            <a:srgbClr val="101010"/>
-          </a:solidFill>
-          <a:ln>
-            <a:noFill/>
-          </a:ln>
-        </p:spPr>
-        <p:style>
-          <a:lnRef idx="1">
-            <a:schemeClr val="accent1"/>
-          </a:lnRef>
-          <a:fillRef idx="3">
-            <a:schemeClr val="accent1"/>
-          </a:fillRef>
-          <a:effectRef idx="2">
-            <a:schemeClr val="accent1"/>
-          </a:effectRef>
-          <a:fontRef idx="minor">
-            <a:schemeClr val="lt1"/>
-          </a:fontRef>
-        </p:style>
-        <p:txBody>
-          <a:bodyPr rtlCol="0" anchor="ctr" wrap="none" lIns="0" rIns="0" tIns="0" bIns="0"/>
-          <a:lstStyle/>
-          <a:p>
-            <a:pPr algn="ctr"/>
-            <a:r>
-              <a:rPr b="1" sz="1500">
-                <a:solidFill>
-                  <a:srgbClr val="FFFFFF"/>
-                </a:solidFill>
-                <a:latin typeface="Arial"/>
-              </a:rPr>
-              <a:t>Uber</a:t>
-            </a:r>
-          </a:p>
-        </p:txBody>
-      </p:sp>
-      <p:sp>
-        <p:nvSpPr>
           <p:cNvPr id="24" name="TextBox 23"/>
           <p:cNvSpPr txBox="1"/>
           <p:nvPr/>
@@ -8020,7 +7378,7 @@
           <a:noFill/>
         </p:spPr>
         <p:txBody>
-          <a:bodyPr wrap="square" anchor="t" lIns="0" rIns="0" tIns="0" bIns="0">
+          <a:bodyPr wrap="square" lIns="0" tIns="0" rIns="0" bIns="0" anchor="t">
             <a:spAutoFit/>
           </a:bodyPr>
           <a:lstStyle/>
@@ -8058,262 +7416,183 @@
           </a:p>
         </p:txBody>
       </p:sp>
-    </p:spTree>
-  </p:cSld>
-  <p:clrMapOvr>
-    <a:masterClrMapping/>
-  </p:clrMapOvr>
-</p:sld>
-</file>
-
-<file path=ppt/slides/slide8.xml><?xml version="1.0" encoding="utf-8"?>
-<p:sld xmlns:a="http://schemas.openxmlformats.org/drawingml/2006/main" xmlns:p="http://schemas.openxmlformats.org/presentationml/2006/main" xmlns:r="http://schemas.openxmlformats.org/officeDocument/2006/relationships">
-  <p:cSld>
-    <p:spTree>
-      <p:nvGrpSpPr>
-        <p:cNvPr id="1" name=""/>
-        <p:cNvGrpSpPr/>
-        <p:nvPr/>
-      </p:nvGrpSpPr>
-      <p:grpSpPr/>
-      <p:sp>
-        <p:nvSpPr>
-          <p:cNvPr id="2" name="Rectangle 1"/>
-          <p:cNvSpPr/>
-          <p:nvPr/>
-        </p:nvSpPr>
-        <p:spPr>
-          <a:xfrm>
-            <a:off x="0" y="0"/>
-            <a:ext cx="12191695" cy="6858000"/>
-          </a:xfrm>
-          <a:prstGeom prst="rect">
-            <a:avLst/>
-          </a:prstGeom>
-          <a:solidFill>
-            <a:srgbClr val="FBF3E9"/>
-          </a:solidFill>
-          <a:ln>
-            <a:noFill/>
-          </a:ln>
-        </p:spPr>
-        <p:style>
-          <a:lnRef idx="1">
-            <a:schemeClr val="accent1"/>
-          </a:lnRef>
-          <a:fillRef idx="3">
-            <a:schemeClr val="accent1"/>
-          </a:fillRef>
-          <a:effectRef idx="2">
-            <a:schemeClr val="accent1"/>
-          </a:effectRef>
-          <a:fontRef idx="minor">
-            <a:schemeClr val="lt1"/>
-          </a:fontRef>
-        </p:style>
-        <p:txBody>
-          <a:bodyPr rtlCol="0" anchor="ctr"/>
-          <a:lstStyle/>
-          <a:p>
-            <a:pPr algn="ctr"/>
-          </a:p>
-        </p:txBody>
-      </p:sp>
-      <p:sp>
-        <p:nvSpPr>
-          <p:cNvPr id="3" name="Rectangle 2"/>
-          <p:cNvSpPr/>
-          <p:nvPr/>
-        </p:nvSpPr>
-        <p:spPr>
-          <a:xfrm>
-            <a:off x="0" y="0"/>
-            <a:ext cx="12191695" cy="6858000"/>
-          </a:xfrm>
-          <a:prstGeom prst="rect">
-            <a:avLst/>
-          </a:prstGeom>
-          <a:solidFill>
-            <a:srgbClr val="261D17"/>
-          </a:solidFill>
-          <a:ln>
-            <a:noFill/>
-          </a:ln>
-        </p:spPr>
-        <p:style>
-          <a:lnRef idx="1">
-            <a:schemeClr val="accent1"/>
-          </a:lnRef>
-          <a:fillRef idx="3">
-            <a:schemeClr val="accent1"/>
-          </a:fillRef>
-          <a:effectRef idx="2">
-            <a:schemeClr val="accent1"/>
-          </a:effectRef>
-          <a:fontRef idx="minor">
-            <a:schemeClr val="lt1"/>
-          </a:fontRef>
-        </p:style>
-        <p:txBody>
-          <a:bodyPr rtlCol="0" anchor="ctr"/>
-          <a:lstStyle/>
-          <a:p>
-            <a:pPr algn="ctr"/>
-          </a:p>
-        </p:txBody>
-      </p:sp>
-      <p:sp>
-        <p:nvSpPr>
-          <p:cNvPr id="4" name="Oval 3"/>
-          <p:cNvSpPr/>
-          <p:nvPr/>
-        </p:nvSpPr>
-        <p:spPr>
-          <a:xfrm>
-            <a:off x="9692640" y="4206240"/>
-            <a:ext cx="3108960" cy="3108960"/>
-          </a:xfrm>
-          <a:prstGeom prst="ellipse">
-            <a:avLst/>
-          </a:prstGeom>
-          <a:solidFill>
-            <a:srgbClr val="ED6A2C"/>
-          </a:solidFill>
-          <a:ln>
-            <a:noFill/>
-          </a:ln>
-        </p:spPr>
-        <p:style>
-          <a:lnRef idx="1">
-            <a:schemeClr val="accent1"/>
-          </a:lnRef>
-          <a:fillRef idx="3">
-            <a:schemeClr val="accent1"/>
-          </a:fillRef>
-          <a:effectRef idx="2">
-            <a:schemeClr val="accent1"/>
-          </a:effectRef>
-          <a:fontRef idx="minor">
-            <a:schemeClr val="lt1"/>
-          </a:fontRef>
-        </p:style>
-        <p:txBody>
-          <a:bodyPr rtlCol="0" anchor="ctr"/>
-          <a:lstStyle/>
-          <a:p>
-            <a:pPr algn="ctr"/>
-          </a:p>
-        </p:txBody>
-      </p:sp>
-      <p:sp>
-        <p:nvSpPr>
-          <p:cNvPr id="5" name="TextBox 4"/>
-          <p:cNvSpPr txBox="1"/>
-          <p:nvPr/>
-        </p:nvSpPr>
-        <p:spPr>
-          <a:xfrm>
-            <a:off x="822960" y="1097280"/>
-            <a:ext cx="10058400" cy="365760"/>
-          </a:xfrm>
-          <a:prstGeom prst="rect">
-            <a:avLst/>
-          </a:prstGeom>
-          <a:noFill/>
-        </p:spPr>
-        <p:txBody>
-          <a:bodyPr wrap="square" anchor="t" lIns="0" rIns="0" tIns="0" bIns="0">
-            <a:spAutoFit/>
-          </a:bodyPr>
-          <a:lstStyle/>
-          <a:p>
-            <a:pPr algn="l"/>
-            <a:r>
-              <a:rPr sz="1300" b="1" i="0" spc="220">
-                <a:solidFill>
-                  <a:srgbClr val="ED6A2C"/>
-                </a:solidFill>
-                <a:latin typeface="Arial"/>
-              </a:rPr>
-              <a:t>PINGIT SDK</a:t>
-            </a:r>
-          </a:p>
-        </p:txBody>
-      </p:sp>
-      <p:sp>
-        <p:nvSpPr>
-          <p:cNvPr id="6" name="TextBox 5"/>
-          <p:cNvSpPr txBox="1"/>
-          <p:nvPr/>
-        </p:nvSpPr>
-        <p:spPr>
-          <a:xfrm>
-            <a:off x="777240" y="2011680"/>
-            <a:ext cx="10241280" cy="2377440"/>
-          </a:xfrm>
-          <a:prstGeom prst="rect">
-            <a:avLst/>
-          </a:prstGeom>
-          <a:noFill/>
-        </p:spPr>
-        <p:txBody>
-          <a:bodyPr wrap="square" anchor="t" lIns="0" rIns="0" tIns="0" bIns="0">
-            <a:spAutoFit/>
-          </a:bodyPr>
-          <a:lstStyle/>
-          <a:p>
-            <a:pPr algn="l">
-              <a:lnSpc>
-                <a:spcPct val="108000"/>
-              </a:lnSpc>
-            </a:pPr>
-            <a:r>
-              <a:rPr sz="4000" b="1" i="0">
-                <a:solidFill>
-                  <a:srgbClr val="FBF3E9"/>
-                </a:solidFill>
-                <a:latin typeface="Arial"/>
-              </a:rPr>
-              <a:t>A few lines of code. Any app. Users who never hit the wall.</a:t>
-            </a:r>
-          </a:p>
-        </p:txBody>
-      </p:sp>
-      <p:sp>
-        <p:nvSpPr>
-          <p:cNvPr id="7" name="TextBox 6"/>
-          <p:cNvSpPr txBox="1"/>
-          <p:nvPr/>
-        </p:nvSpPr>
-        <p:spPr>
-          <a:xfrm>
-            <a:off x="822960" y="5120640"/>
-            <a:ext cx="8229600" cy="457200"/>
-          </a:xfrm>
-          <a:prstGeom prst="rect">
-            <a:avLst/>
-          </a:prstGeom>
-          <a:noFill/>
-        </p:spPr>
-        <p:txBody>
-          <a:bodyPr wrap="square" anchor="t" lIns="0" rIns="0" tIns="0" bIns="0">
-            <a:spAutoFit/>
-          </a:bodyPr>
-          <a:lstStyle/>
-          <a:p>
-            <a:pPr algn="l"/>
-            <a:r>
-              <a:rPr sz="1600" b="0" i="0">
-                <a:solidFill>
-                  <a:srgbClr val="ED6A2C"/>
-                </a:solidFill>
-                <a:latin typeface="Consolas"/>
-              </a:rPr>
-              <a:t>github.com/bitbit138/pingit-sdk</a:t>
-            </a:r>
-          </a:p>
-        </p:txBody>
-      </p:sp>
+      <p:pic>
+        <p:nvPicPr>
+          <p:cNvPr id="26" name="Picture 25" descr="Instagram logo vector">
+            <a:extLst>
+              <a:ext uri="{FF2B5EF4-FFF2-40B4-BE49-F238E27FC236}">
+                <a16:creationId xmlns:a16="http://schemas.microsoft.com/office/drawing/2014/main" id="{B618A9A1-570F-B59C-C04C-13DB93DD0DAB}"/>
+              </a:ext>
+            </a:extLst>
+          </p:cNvPr>
+          <p:cNvPicPr>
+            <a:picLocks noChangeAspect="1"/>
+          </p:cNvPicPr>
+          <p:nvPr/>
+        </p:nvPicPr>
+        <p:blipFill>
+          <a:blip r:embed="rId2"/>
+          <a:stretch>
+            <a:fillRect/>
+          </a:stretch>
+        </p:blipFill>
+        <p:spPr>
+          <a:xfrm>
+            <a:off x="873984" y="2011680"/>
+            <a:ext cx="697320" cy="697320"/>
+          </a:xfrm>
+          <a:prstGeom prst="rect">
+            <a:avLst/>
+          </a:prstGeom>
+        </p:spPr>
+      </p:pic>
+      <p:pic>
+        <p:nvPicPr>
+          <p:cNvPr id="27" name="Picture 26" descr="Google Drive for Business - Review 2026 - PCMag UK">
+            <a:extLst>
+              <a:ext uri="{FF2B5EF4-FFF2-40B4-BE49-F238E27FC236}">
+                <a16:creationId xmlns:a16="http://schemas.microsoft.com/office/drawing/2014/main" id="{AD62DB16-8E45-2C50-46FE-3695805BFB8B}"/>
+              </a:ext>
+            </a:extLst>
+          </p:cNvPr>
+          <p:cNvPicPr>
+            <a:picLocks noChangeAspect="1"/>
+          </p:cNvPicPr>
+          <p:nvPr/>
+        </p:nvPicPr>
+        <p:blipFill>
+          <a:blip r:embed="rId3"/>
+          <a:stretch/>
+        </p:blipFill>
+        <p:spPr>
+          <a:xfrm>
+            <a:off x="6426917" y="1965960"/>
+            <a:ext cx="990180" cy="554900"/>
+          </a:xfrm>
+          <a:prstGeom prst="rect">
+            <a:avLst/>
+          </a:prstGeom>
+        </p:spPr>
+      </p:pic>
+      <p:pic>
+        <p:nvPicPr>
+          <p:cNvPr id="28" name="Picture 27" descr="Whatsapp logo Vectors - Download Free High-Quality Vectors | Magnific (formerly Freepik)">
+            <a:extLst>
+              <a:ext uri="{FF2B5EF4-FFF2-40B4-BE49-F238E27FC236}">
+                <a16:creationId xmlns:a16="http://schemas.microsoft.com/office/drawing/2014/main" id="{95568CA5-D737-34A1-CC7D-E2D24B736F54}"/>
+              </a:ext>
+            </a:extLst>
+          </p:cNvPr>
+          <p:cNvPicPr>
+            <a:picLocks noChangeAspect="1"/>
+          </p:cNvPicPr>
+          <p:nvPr/>
+        </p:nvPicPr>
+        <p:blipFill>
+          <a:blip r:embed="rId4"/>
+          <a:stretch/>
+        </p:blipFill>
+        <p:spPr>
+          <a:xfrm>
+            <a:off x="777240" y="4709123"/>
+            <a:ext cx="905293" cy="905293"/>
+          </a:xfrm>
+          <a:prstGeom prst="rect">
+            <a:avLst/>
+          </a:prstGeom>
+        </p:spPr>
+      </p:pic>
+      <p:pic>
+        <p:nvPicPr>
+          <p:cNvPr id="29" name="Picture 28" descr="File:Xbox app logo.svg - Wikimedia Commons">
+            <a:extLst>
+              <a:ext uri="{FF2B5EF4-FFF2-40B4-BE49-F238E27FC236}">
+                <a16:creationId xmlns:a16="http://schemas.microsoft.com/office/drawing/2014/main" id="{EA1C680F-DAF6-CF89-4B7A-AC14A3247860}"/>
+              </a:ext>
+            </a:extLst>
+          </p:cNvPr>
+          <p:cNvPicPr>
+            <a:picLocks noChangeAspect="1"/>
+          </p:cNvPicPr>
+          <p:nvPr/>
+        </p:nvPicPr>
+        <p:blipFill>
+          <a:blip r:embed="rId5"/>
+          <a:stretch>
+            <a:fillRect/>
+          </a:stretch>
+        </p:blipFill>
+        <p:spPr>
+          <a:xfrm>
+            <a:off x="6547741" y="3422740"/>
+            <a:ext cx="748532" cy="748532"/>
+          </a:xfrm>
+          <a:prstGeom prst="rect">
+            <a:avLst/>
+          </a:prstGeom>
+        </p:spPr>
+      </p:pic>
+      <p:pic>
+        <p:nvPicPr>
+          <p:cNvPr id="30" name="Picture 29" descr="Netflix isn't changing its logo, but has a new icon | The Verge">
+            <a:extLst>
+              <a:ext uri="{FF2B5EF4-FFF2-40B4-BE49-F238E27FC236}">
+                <a16:creationId xmlns:a16="http://schemas.microsoft.com/office/drawing/2014/main" id="{912B129F-2FB1-5F1B-85AC-0ABF95DD0579}"/>
+              </a:ext>
+            </a:extLst>
+          </p:cNvPr>
+          <p:cNvPicPr>
+            <a:picLocks noChangeAspect="1"/>
+          </p:cNvPicPr>
+          <p:nvPr/>
+        </p:nvPicPr>
+        <p:blipFill>
+          <a:blip r:embed="rId6"/>
+          <a:srcRect l="24658" t="-4597" r="22972" b="-1"/>
+          <a:stretch>
+            <a:fillRect/>
+          </a:stretch>
+        </p:blipFill>
+        <p:spPr>
+          <a:xfrm>
+            <a:off x="1015735" y="3403241"/>
+            <a:ext cx="474100" cy="635022"/>
+          </a:xfrm>
+          <a:prstGeom prst="rect">
+            <a:avLst/>
+          </a:prstGeom>
+        </p:spPr>
+      </p:pic>
+      <p:pic>
+        <p:nvPicPr>
+          <p:cNvPr id="31" name="Picture 30" descr="Uber's New Logo Has Been Unveiled, and Twitter Has Thoughts | Marie Claire">
+            <a:extLst>
+              <a:ext uri="{FF2B5EF4-FFF2-40B4-BE49-F238E27FC236}">
+                <a16:creationId xmlns:a16="http://schemas.microsoft.com/office/drawing/2014/main" id="{1CCA96CE-7086-0FA8-B51A-A4D23B5C7802}"/>
+              </a:ext>
+            </a:extLst>
+          </p:cNvPr>
+          <p:cNvPicPr>
+            <a:picLocks noChangeAspect="1"/>
+          </p:cNvPicPr>
+          <p:nvPr/>
+        </p:nvPicPr>
+        <p:blipFill>
+          <a:blip r:embed="rId7"/>
+          <a:stretch>
+            <a:fillRect/>
+          </a:stretch>
+        </p:blipFill>
+        <p:spPr>
+          <a:xfrm>
+            <a:off x="6477277" y="4892040"/>
+            <a:ext cx="837782" cy="469975"/>
+          </a:xfrm>
+          <a:prstGeom prst="rect">
+            <a:avLst/>
+          </a:prstGeom>
+        </p:spPr>
+      </p:pic>
     </p:spTree>
   </p:cSld>
   <p:clrMapOvr>

</xml_diff>